<commit_message>
Cours magistral : suppression des notes pour l'orateur
Co-Authored-By: Claude Opus 5.5 <noreply@anthropic.com>
</commit_message>
<xml_diff>
--- a/Cours_magistral/CM1_Histoire_IA.pptx
+++ b/Cours_magistral/CM1_Histoire_IA.pptx
@@ -1297,2715 +1297,6 @@
     </a:lvl9pPr>
   </p:notesStyle>
 </p:notesMaster>
-</file>
-
-<file path=ppt/notesSlides/notesSlide1.xml><?xml version="1.0" encoding="utf-8"?>
-<p:notes xmlns:a="http://schemas.openxmlformats.org/drawingml/2006/main" xmlns:p="http://schemas.openxmlformats.org/presentationml/2006/main" xmlns:r="http://schemas.openxmlformats.org/officeDocument/2006/relationships">
-  <p:cSld>
-    <p:spTree>
-      <p:nvGrpSpPr>
-        <p:cNvPr id="1" name=""/>
-        <p:cNvGrpSpPr/>
-        <p:nvPr/>
-      </p:nvGrpSpPr>
-      <p:grpSpPr>
-        <a:xfrm>
-          <a:off x="0" y="0"/>
-          <a:ext cx="0" cy="0"/>
-          <a:chOff x="0" y="0"/>
-          <a:chExt cx="0" cy="0"/>
-        </a:xfrm>
-      </p:grpSpPr>
-      <p:sp>
-        <p:nvSpPr>
-          <p:cNvPr id="2" name="Slide Image Placeholder 1"/>
-          <p:cNvSpPr>
-            <a:spLocks noGrp="1"/>
-          </p:cNvSpPr>
-          <p:nvPr>
-            <p:ph type="sldImg" idx="2"/>
-          </p:nvPr>
-        </p:nvSpPr>
-        <p:spPr/>
-      </p:sp>
-      <p:sp>
-        <p:nvSpPr>
-          <p:cNvPr id="3" name="Notes Placeholder 2"/>
-          <p:cNvSpPr>
-            <a:spLocks noGrp="1"/>
-          </p:cNvSpPr>
-          <p:nvPr>
-            <p:ph type="body" idx="3" sz="quarter"/>
-          </p:nvPr>
-        </p:nvSpPr>
-        <p:spPr/>
-        <p:txBody>
-          <a:bodyPr/>
-          <a:lstStyle/>
-          <a:p>
-            <a:r>
-              <a:t>Durée totale de la partie : 35 à 40 minutes.</a:t>
-            </a:r>
-          </a:p>
-          <a:p/>
-          <a:p>
-            <a:r>
-              <a:t>Objectif : donner aux étudiants une vision d'ensemble de l'IA, de ses origines à aujourd'hui, pour situer ce qu'ils feront en TP. Chaque époque a une couleur, que l'on retrouve sur la frise, sur les intercalaires et dans les cartes.</a:t>
-            </a:r>
-          </a:p>
-        </p:txBody>
-      </p:sp>
-      <p:sp>
-        <p:nvSpPr>
-          <p:cNvPr id="4" name="Slide Number Placeholder 3"/>
-          <p:cNvSpPr>
-            <a:spLocks noGrp="1"/>
-          </p:cNvSpPr>
-          <p:nvPr>
-            <p:ph type="sldNum" idx="5" sz="quarter"/>
-          </p:nvPr>
-        </p:nvSpPr>
-        <p:spPr/>
-      </p:sp>
-    </p:spTree>
-  </p:cSld>
-  <p:clrMapOvr>
-    <a:masterClrMapping/>
-  </p:clrMapOvr>
-</p:notes>
-</file>
-
-<file path=ppt/notesSlides/notesSlide10.xml><?xml version="1.0" encoding="utf-8"?>
-<p:notes xmlns:a="http://schemas.openxmlformats.org/drawingml/2006/main" xmlns:p="http://schemas.openxmlformats.org/presentationml/2006/main" xmlns:r="http://schemas.openxmlformats.org/officeDocument/2006/relationships">
-  <p:cSld>
-    <p:spTree>
-      <p:nvGrpSpPr>
-        <p:cNvPr id="1" name=""/>
-        <p:cNvGrpSpPr/>
-        <p:nvPr/>
-      </p:nvGrpSpPr>
-      <p:grpSpPr>
-        <a:xfrm>
-          <a:off x="0" y="0"/>
-          <a:ext cx="0" cy="0"/>
-          <a:chOff x="0" y="0"/>
-          <a:chExt cx="0" cy="0"/>
-        </a:xfrm>
-      </p:grpSpPr>
-      <p:sp>
-        <p:nvSpPr>
-          <p:cNvPr id="2" name="Slide Image Placeholder 1"/>
-          <p:cNvSpPr>
-            <a:spLocks noGrp="1"/>
-          </p:cNvSpPr>
-          <p:nvPr>
-            <p:ph type="sldImg" idx="2"/>
-          </p:nvPr>
-        </p:nvSpPr>
-        <p:spPr/>
-      </p:sp>
-      <p:sp>
-        <p:nvSpPr>
-          <p:cNvPr id="3" name="Notes Placeholder 2"/>
-          <p:cNvSpPr>
-            <a:spLocks noGrp="1"/>
-          </p:cNvSpPr>
-          <p:nvPr>
-            <p:ph type="body" idx="3" sz="quarter"/>
-          </p:nvPr>
-        </p:nvSpPr>
-        <p:spPr/>
-        <p:txBody>
-          <a:bodyPr/>
-          <a:lstStyle/>
-          <a:p>
-            <a:r>
-              <a:t>≈ 2 min.</a:t>
-            </a:r>
-          </a:p>
-          <a:p/>
-          <a:p>
-            <a:r>
-              <a:t>Logic Theorist est souvent considéré comme le premier programme d'IA : il démontre des théorèmes des Principia Mathematica de Russell et Whitehead.</a:t>
-            </a:r>
-          </a:p>
-          <a:p/>
-          <a:p>
-            <a:r>
-              <a:t>Le Perceptron (Rosenblatt, 1957-1958) est la première machine qui apprend : c'est un neurone formel dont les poids s'ajustent automatiquement. Le New York Times annonce alors une machine qui pourra bientôt marcher, parler et être consciente d'elle-même !</a:t>
-            </a:r>
-          </a:p>
-          <a:p/>
-          <a:p>
-            <a:r>
-              <a:t>Arthur Samuel : premier programme qui apprend par l'expérience ; il finit par battre son créateur. C'est lui qui popularise le terme « machine learning » (1959).</a:t>
-            </a:r>
-          </a:p>
-          <a:p/>
-          <a:p>
-            <a:r>
-              <a:t>L'optimisme des chercheurs est immense, ce qui prépare la désillusion.</a:t>
-            </a:r>
-          </a:p>
-        </p:txBody>
-      </p:sp>
-      <p:sp>
-        <p:nvSpPr>
-          <p:cNvPr id="4" name="Slide Number Placeholder 3"/>
-          <p:cNvSpPr>
-            <a:spLocks noGrp="1"/>
-          </p:cNvSpPr>
-          <p:nvPr>
-            <p:ph type="sldNum" idx="5" sz="quarter"/>
-          </p:nvPr>
-        </p:nvSpPr>
-        <p:spPr/>
-      </p:sp>
-    </p:spTree>
-  </p:cSld>
-  <p:clrMapOvr>
-    <a:masterClrMapping/>
-  </p:clrMapOvr>
-</p:notes>
-</file>
-
-<file path=ppt/notesSlides/notesSlide11.xml><?xml version="1.0" encoding="utf-8"?>
-<p:notes xmlns:a="http://schemas.openxmlformats.org/drawingml/2006/main" xmlns:p="http://schemas.openxmlformats.org/presentationml/2006/main" xmlns:r="http://schemas.openxmlformats.org/officeDocument/2006/relationships">
-  <p:cSld>
-    <p:spTree>
-      <p:nvGrpSpPr>
-        <p:cNvPr id="1" name=""/>
-        <p:cNvGrpSpPr/>
-        <p:nvPr/>
-      </p:nvGrpSpPr>
-      <p:grpSpPr>
-        <a:xfrm>
-          <a:off x="0" y="0"/>
-          <a:ext cx="0" cy="0"/>
-          <a:chOff x="0" y="0"/>
-          <a:chExt cx="0" cy="0"/>
-        </a:xfrm>
-      </p:grpSpPr>
-      <p:sp>
-        <p:nvSpPr>
-          <p:cNvPr id="2" name="Slide Image Placeholder 1"/>
-          <p:cNvSpPr>
-            <a:spLocks noGrp="1"/>
-          </p:cNvSpPr>
-          <p:nvPr>
-            <p:ph type="sldImg" idx="2"/>
-          </p:nvPr>
-        </p:nvSpPr>
-        <p:spPr/>
-      </p:sp>
-      <p:sp>
-        <p:nvSpPr>
-          <p:cNvPr id="3" name="Notes Placeholder 2"/>
-          <p:cNvSpPr>
-            <a:spLocks noGrp="1"/>
-          </p:cNvSpPr>
-          <p:nvPr>
-            <p:ph type="body" idx="3" sz="quarter"/>
-          </p:nvPr>
-        </p:nvSpPr>
-        <p:spPr/>
-        <p:txBody>
-          <a:bodyPr/>
-          <a:lstStyle/>
-          <a:p>
-            <a:r>
-              <a:t>≈ 2 min.</a:t>
-            </a:r>
-          </a:p>
-          <a:p/>
-          <a:p>
-            <a:r>
-              <a:t>ELIZA (1964-1966) simule un psychothérapeute rogérien, qui relance le patient en reformulant ses phrases : un contexte idéal pour masquer l'absence de compréhension.</a:t>
-            </a:r>
-          </a:p>
-          <a:p/>
-          <a:p>
-            <a:r>
-              <a:t>Anecdote : la secrétaire de Weizenbaum lui aurait demandé de quitter la pièce pour parler « en privé » avec ELIZA. Weizenbaum est devenu ensuite un critique de l'IA.</a:t>
-            </a:r>
-          </a:p>
-          <a:p/>
-          <a:p>
-            <a:r>
-              <a:t>Faire le lien avec aujourd'hui : les chatbots modernes sont incomparablement plus puissants, mais le biais humain qui consiste à leur prêter des intentions est le même.</a:t>
-            </a:r>
-          </a:p>
-        </p:txBody>
-      </p:sp>
-      <p:sp>
-        <p:nvSpPr>
-          <p:cNvPr id="4" name="Slide Number Placeholder 3"/>
-          <p:cNvSpPr>
-            <a:spLocks noGrp="1"/>
-          </p:cNvSpPr>
-          <p:nvPr>
-            <p:ph type="sldNum" idx="5" sz="quarter"/>
-          </p:nvPr>
-        </p:nvSpPr>
-        <p:spPr/>
-      </p:sp>
-    </p:spTree>
-  </p:cSld>
-  <p:clrMapOvr>
-    <a:masterClrMapping/>
-  </p:clrMapOvr>
-</p:notes>
-</file>
-
-<file path=ppt/notesSlides/notesSlide12.xml><?xml version="1.0" encoding="utf-8"?>
-<p:notes xmlns:a="http://schemas.openxmlformats.org/drawingml/2006/main" xmlns:p="http://schemas.openxmlformats.org/presentationml/2006/main" xmlns:r="http://schemas.openxmlformats.org/officeDocument/2006/relationships">
-  <p:cSld>
-    <p:spTree>
-      <p:nvGrpSpPr>
-        <p:cNvPr id="1" name=""/>
-        <p:cNvGrpSpPr/>
-        <p:nvPr/>
-      </p:nvGrpSpPr>
-      <p:grpSpPr>
-        <a:xfrm>
-          <a:off x="0" y="0"/>
-          <a:ext cx="0" cy="0"/>
-          <a:chOff x="0" y="0"/>
-          <a:chExt cx="0" cy="0"/>
-        </a:xfrm>
-      </p:grpSpPr>
-      <p:sp>
-        <p:nvSpPr>
-          <p:cNvPr id="2" name="Slide Image Placeholder 1"/>
-          <p:cNvSpPr>
-            <a:spLocks noGrp="1"/>
-          </p:cNvSpPr>
-          <p:nvPr>
-            <p:ph type="sldImg" idx="2"/>
-          </p:nvPr>
-        </p:nvSpPr>
-        <p:spPr/>
-      </p:sp>
-      <p:sp>
-        <p:nvSpPr>
-          <p:cNvPr id="3" name="Notes Placeholder 2"/>
-          <p:cNvSpPr>
-            <a:spLocks noGrp="1"/>
-          </p:cNvSpPr>
-          <p:nvPr>
-            <p:ph type="body" idx="3" sz="quarter"/>
-          </p:nvPr>
-        </p:nvSpPr>
-        <p:spPr/>
-        <p:txBody>
-          <a:bodyPr/>
-          <a:lstStyle/>
-          <a:p>
-            <a:r>
-              <a:t>≈ 2 min.</a:t>
-            </a:r>
-          </a:p>
-          <a:p/>
-          <a:p>
-            <a:r>
-              <a:t>Trois causes à retenir : promesses excessives, limites mathématiques, manque de puissance de calcul.</a:t>
-            </a:r>
-          </a:p>
-          <a:p/>
-          <a:p>
-            <a:r>
-              <a:t>Le « OU exclusif » (XOR) : la sortie vaut 1 si exactement une des deux entrées vaut 1. Sur le petit schéma, les points pleins (sortie 1) sont sur une diagonale, les points vides sur l'autre : aucune droite ne peut les séparer. Or un perceptron à une couche ne sait tracer qu'une droite. La solution (plusieurs couches de neurones) existait en théorie, mais on ne savait pas encore les entraîner : il faudra attendre 1986.</a:t>
-            </a:r>
-          </a:p>
-          <a:p/>
-          <a:p>
-            <a:r>
-              <a:t>Explosion combinatoire : aux échecs, le nombre de parties possibles dépasse de loin le nombre d'atomes de l'univers ; tout explorer est impossible.</a:t>
-            </a:r>
-          </a:p>
-        </p:txBody>
-      </p:sp>
-      <p:sp>
-        <p:nvSpPr>
-          <p:cNvPr id="4" name="Slide Number Placeholder 3"/>
-          <p:cNvSpPr>
-            <a:spLocks noGrp="1"/>
-          </p:cNvSpPr>
-          <p:nvPr>
-            <p:ph type="sldNum" idx="5" sz="quarter"/>
-          </p:nvPr>
-        </p:nvSpPr>
-        <p:spPr/>
-      </p:sp>
-    </p:spTree>
-  </p:cSld>
-  <p:clrMapOvr>
-    <a:masterClrMapping/>
-  </p:clrMapOvr>
-</p:notes>
-</file>
-
-<file path=ppt/notesSlides/notesSlide13.xml><?xml version="1.0" encoding="utf-8"?>
-<p:notes xmlns:a="http://schemas.openxmlformats.org/drawingml/2006/main" xmlns:p="http://schemas.openxmlformats.org/presentationml/2006/main" xmlns:r="http://schemas.openxmlformats.org/officeDocument/2006/relationships">
-  <p:cSld>
-    <p:spTree>
-      <p:nvGrpSpPr>
-        <p:cNvPr id="1" name=""/>
-        <p:cNvGrpSpPr/>
-        <p:nvPr/>
-      </p:nvGrpSpPr>
-      <p:grpSpPr>
-        <a:xfrm>
-          <a:off x="0" y="0"/>
-          <a:ext cx="0" cy="0"/>
-          <a:chOff x="0" y="0"/>
-          <a:chExt cx="0" cy="0"/>
-        </a:xfrm>
-      </p:grpSpPr>
-      <p:sp>
-        <p:nvSpPr>
-          <p:cNvPr id="2" name="Slide Image Placeholder 1"/>
-          <p:cNvSpPr>
-            <a:spLocks noGrp="1"/>
-          </p:cNvSpPr>
-          <p:nvPr>
-            <p:ph type="sldImg" idx="2"/>
-          </p:nvPr>
-        </p:nvSpPr>
-        <p:spPr/>
-      </p:sp>
-      <p:sp>
-        <p:nvSpPr>
-          <p:cNvPr id="3" name="Notes Placeholder 2"/>
-          <p:cNvSpPr>
-            <a:spLocks noGrp="1"/>
-          </p:cNvSpPr>
-          <p:nvPr>
-            <p:ph type="body" idx="3" sz="quarter"/>
-          </p:nvPr>
-        </p:nvSpPr>
-        <p:spPr/>
-        <p:txBody>
-          <a:bodyPr/>
-          <a:lstStyle/>
-          <a:p>
-            <a:r>
-              <a:t>≈ 15 s. Au début des années 1980, l'IA renaît avec une approche pragmatique et commerciale.</a:t>
-            </a:r>
-          </a:p>
-        </p:txBody>
-      </p:sp>
-      <p:sp>
-        <p:nvSpPr>
-          <p:cNvPr id="4" name="Slide Number Placeholder 3"/>
-          <p:cNvSpPr>
-            <a:spLocks noGrp="1"/>
-          </p:cNvSpPr>
-          <p:nvPr>
-            <p:ph type="sldNum" idx="5" sz="quarter"/>
-          </p:nvPr>
-        </p:nvSpPr>
-        <p:spPr/>
-      </p:sp>
-    </p:spTree>
-  </p:cSld>
-  <p:clrMapOvr>
-    <a:masterClrMapping/>
-  </p:clrMapOvr>
-</p:notes>
-</file>
-
-<file path=ppt/notesSlides/notesSlide14.xml><?xml version="1.0" encoding="utf-8"?>
-<p:notes xmlns:a="http://schemas.openxmlformats.org/drawingml/2006/main" xmlns:p="http://schemas.openxmlformats.org/presentationml/2006/main" xmlns:r="http://schemas.openxmlformats.org/officeDocument/2006/relationships">
-  <p:cSld>
-    <p:spTree>
-      <p:nvGrpSpPr>
-        <p:cNvPr id="1" name=""/>
-        <p:cNvGrpSpPr/>
-        <p:nvPr/>
-      </p:nvGrpSpPr>
-      <p:grpSpPr>
-        <a:xfrm>
-          <a:off x="0" y="0"/>
-          <a:ext cx="0" cy="0"/>
-          <a:chOff x="0" y="0"/>
-          <a:chExt cx="0" cy="0"/>
-        </a:xfrm>
-      </p:grpSpPr>
-      <p:sp>
-        <p:nvSpPr>
-          <p:cNvPr id="2" name="Slide Image Placeholder 1"/>
-          <p:cNvSpPr>
-            <a:spLocks noGrp="1"/>
-          </p:cNvSpPr>
-          <p:nvPr>
-            <p:ph type="sldImg" idx="2"/>
-          </p:nvPr>
-        </p:nvSpPr>
-        <p:spPr/>
-      </p:sp>
-      <p:sp>
-        <p:nvSpPr>
-          <p:cNvPr id="3" name="Notes Placeholder 2"/>
-          <p:cNvSpPr>
-            <a:spLocks noGrp="1"/>
-          </p:cNvSpPr>
-          <p:nvPr>
-            <p:ph type="body" idx="3" sz="quarter"/>
-          </p:nvPr>
-        </p:nvSpPr>
-        <p:spPr/>
-        <p:txBody>
-          <a:bodyPr/>
-          <a:lstStyle/>
-          <a:p>
-            <a:r>
-              <a:t>≈ 2 min 30.</a:t>
-            </a:r>
-          </a:p>
-          <a:p/>
-          <a:p>
-            <a:r>
-              <a:t>Idée : plutôt que de viser une intelligence générale, on se concentre sur un domaine précis et on « code » le savoir d'un expert sous forme de règles SI… ALORS…. Un moteur d'inférence enchaîne les règles pour aboutir à une conclusion, et peut expliquer son raisonnement (« j'ai conclu X parce que les règles 12 et 37 s'appliquaient ») : un atout majeur.</a:t>
-            </a:r>
-          </a:p>
-          <a:p/>
-          <a:p>
-            <a:r>
-              <a:t>MYCIN n'a jamais été utilisé en pratique (questions de responsabilité juridique et d'intégration à l'hôpital), mais il a démontré la faisabilité. XCON a été le grand succès commercial : les entreprises investissent massivement, le Japon lance un grand programme national (« ordinateurs de cinquième génération », 1982).</a:t>
-            </a:r>
-          </a:p>
-        </p:txBody>
-      </p:sp>
-      <p:sp>
-        <p:nvSpPr>
-          <p:cNvPr id="4" name="Slide Number Placeholder 3"/>
-          <p:cNvSpPr>
-            <a:spLocks noGrp="1"/>
-          </p:cNvSpPr>
-          <p:nvPr>
-            <p:ph type="sldNum" idx="5" sz="quarter"/>
-          </p:nvPr>
-        </p:nvSpPr>
-        <p:spPr/>
-      </p:sp>
-    </p:spTree>
-  </p:cSld>
-  <p:clrMapOvr>
-    <a:masterClrMapping/>
-  </p:clrMapOvr>
-</p:notes>
-</file>
-
-<file path=ppt/notesSlides/notesSlide15.xml><?xml version="1.0" encoding="utf-8"?>
-<p:notes xmlns:a="http://schemas.openxmlformats.org/drawingml/2006/main" xmlns:p="http://schemas.openxmlformats.org/presentationml/2006/main" xmlns:r="http://schemas.openxmlformats.org/officeDocument/2006/relationships">
-  <p:cSld>
-    <p:spTree>
-      <p:nvGrpSpPr>
-        <p:cNvPr id="1" name=""/>
-        <p:cNvGrpSpPr/>
-        <p:nvPr/>
-      </p:nvGrpSpPr>
-      <p:grpSpPr>
-        <a:xfrm>
-          <a:off x="0" y="0"/>
-          <a:ext cx="0" cy="0"/>
-          <a:chOff x="0" y="0"/>
-          <a:chExt cx="0" cy="0"/>
-        </a:xfrm>
-      </p:grpSpPr>
-      <p:sp>
-        <p:nvSpPr>
-          <p:cNvPr id="2" name="Slide Image Placeholder 1"/>
-          <p:cNvSpPr>
-            <a:spLocks noGrp="1"/>
-          </p:cNvSpPr>
-          <p:nvPr>
-            <p:ph type="sldImg" idx="2"/>
-          </p:nvPr>
-        </p:nvSpPr>
-        <p:spPr/>
-      </p:sp>
-      <p:sp>
-        <p:nvSpPr>
-          <p:cNvPr id="3" name="Notes Placeholder 2"/>
-          <p:cNvSpPr>
-            <a:spLocks noGrp="1"/>
-          </p:cNvSpPr>
-          <p:nvPr>
-            <p:ph type="body" idx="3" sz="quarter"/>
-          </p:nvPr>
-        </p:nvSpPr>
-        <p:spPr/>
-        <p:txBody>
-          <a:bodyPr/>
-          <a:lstStyle/>
-          <a:p>
-            <a:r>
-              <a:t>≈ 1 min 30.</a:t>
-            </a:r>
-          </a:p>
-          <a:p/>
-          <a:p>
-            <a:r>
-              <a:t>Les systèmes experts atteignent leurs limites : ils sont chers, fragiles hors de leur domaine et incapables d'apprendre. En 1987, les « machines LISP » (ordinateurs spécialisés pour l'IA) sont balayées par les stations de travail et PC généralistes.</a:t>
-            </a:r>
-          </a:p>
-          <a:p/>
-          <a:p>
-            <a:r>
-              <a:t>Mais la leçon est fondamentale et prépare la suite : pour reconnaître un chat, personne ne sait écrire les règles (« un chat a deux oreilles pointues… » ne marche pas). En revanche, on peut facilement fournir des milliers de photos de chats. D'où l'idée de l'apprentissage automatique.</a:t>
-            </a:r>
-          </a:p>
-        </p:txBody>
-      </p:sp>
-      <p:sp>
-        <p:nvSpPr>
-          <p:cNvPr id="4" name="Slide Number Placeholder 3"/>
-          <p:cNvSpPr>
-            <a:spLocks noGrp="1"/>
-          </p:cNvSpPr>
-          <p:nvPr>
-            <p:ph type="sldNum" idx="5" sz="quarter"/>
-          </p:nvPr>
-        </p:nvSpPr>
-        <p:spPr/>
-      </p:sp>
-    </p:spTree>
-  </p:cSld>
-  <p:clrMapOvr>
-    <a:masterClrMapping/>
-  </p:clrMapOvr>
-</p:notes>
-</file>
-
-<file path=ppt/notesSlides/notesSlide16.xml><?xml version="1.0" encoding="utf-8"?>
-<p:notes xmlns:a="http://schemas.openxmlformats.org/drawingml/2006/main" xmlns:p="http://schemas.openxmlformats.org/presentationml/2006/main" xmlns:r="http://schemas.openxmlformats.org/officeDocument/2006/relationships">
-  <p:cSld>
-    <p:spTree>
-      <p:nvGrpSpPr>
-        <p:cNvPr id="1" name=""/>
-        <p:cNvGrpSpPr/>
-        <p:nvPr/>
-      </p:nvGrpSpPr>
-      <p:grpSpPr>
-        <a:xfrm>
-          <a:off x="0" y="0"/>
-          <a:ext cx="0" cy="0"/>
-          <a:chOff x="0" y="0"/>
-          <a:chExt cx="0" cy="0"/>
-        </a:xfrm>
-      </p:grpSpPr>
-      <p:sp>
-        <p:nvSpPr>
-          <p:cNvPr id="2" name="Slide Image Placeholder 1"/>
-          <p:cNvSpPr>
-            <a:spLocks noGrp="1"/>
-          </p:cNvSpPr>
-          <p:nvPr>
-            <p:ph type="sldImg" idx="2"/>
-          </p:nvPr>
-        </p:nvSpPr>
-        <p:spPr/>
-      </p:sp>
-      <p:sp>
-        <p:nvSpPr>
-          <p:cNvPr id="3" name="Notes Placeholder 2"/>
-          <p:cNvSpPr>
-            <a:spLocks noGrp="1"/>
-          </p:cNvSpPr>
-          <p:nvPr>
-            <p:ph type="body" idx="3" sz="quarter"/>
-          </p:nvPr>
-        </p:nvSpPr>
-        <p:spPr/>
-        <p:txBody>
-          <a:bodyPr/>
-          <a:lstStyle/>
-          <a:p>
-            <a:r>
-              <a:t>≈ 3 min — diapositive clé du cours.</a:t>
-            </a:r>
-          </a:p>
-          <a:p/>
-          <a:p>
-            <a:r>
-              <a:t>Programmation classique : le développeur écrit les règles ; la machine les applique aux données pour produire des réponses.</a:t>
-            </a:r>
-          </a:p>
-          <a:p/>
-          <a:p>
-            <a:r>
-              <a:t>Apprentissage automatique : on fournit des données ET les réponses attendues (les étiquettes) ; l'algorithme en déduit les règles, c'est-à-dire un modèle, qu'on appliquera ensuite à de nouvelles données.</a:t>
-            </a:r>
-          </a:p>
-          <a:p/>
-          <a:p>
-            <a:r>
-              <a:t>L'exemple du filtre anti-spam est parlant pour des informaticiens : maintenir des règles à la main est une course sans fin, alors qu'un modèle entraîné sur des exemples s'adapte.</a:t>
-            </a:r>
-          </a:p>
-          <a:p/>
-          <a:p>
-            <a:r>
-              <a:t>Annoncer que c'est exactement ce qu'ils feront en TP : fournir des données à un algorithme (K-Means, arbres, XGBoost…) pour qu'il en tire un modèle.</a:t>
-            </a:r>
-          </a:p>
-        </p:txBody>
-      </p:sp>
-      <p:sp>
-        <p:nvSpPr>
-          <p:cNvPr id="4" name="Slide Number Placeholder 3"/>
-          <p:cNvSpPr>
-            <a:spLocks noGrp="1"/>
-          </p:cNvSpPr>
-          <p:nvPr>
-            <p:ph type="sldNum" idx="5" sz="quarter"/>
-          </p:nvPr>
-        </p:nvSpPr>
-        <p:spPr/>
-      </p:sp>
-    </p:spTree>
-  </p:cSld>
-  <p:clrMapOvr>
-    <a:masterClrMapping/>
-  </p:clrMapOvr>
-</p:notes>
-</file>
-
-<file path=ppt/notesSlides/notesSlide17.xml><?xml version="1.0" encoding="utf-8"?>
-<p:notes xmlns:a="http://schemas.openxmlformats.org/drawingml/2006/main" xmlns:p="http://schemas.openxmlformats.org/presentationml/2006/main" xmlns:r="http://schemas.openxmlformats.org/officeDocument/2006/relationships">
-  <p:cSld>
-    <p:spTree>
-      <p:nvGrpSpPr>
-        <p:cNvPr id="1" name=""/>
-        <p:cNvGrpSpPr/>
-        <p:nvPr/>
-      </p:nvGrpSpPr>
-      <p:grpSpPr>
-        <a:xfrm>
-          <a:off x="0" y="0"/>
-          <a:ext cx="0" cy="0"/>
-          <a:chOff x="0" y="0"/>
-          <a:chExt cx="0" cy="0"/>
-        </a:xfrm>
-      </p:grpSpPr>
-      <p:sp>
-        <p:nvSpPr>
-          <p:cNvPr id="2" name="Slide Image Placeholder 1"/>
-          <p:cNvSpPr>
-            <a:spLocks noGrp="1"/>
-          </p:cNvSpPr>
-          <p:nvPr>
-            <p:ph type="sldImg" idx="2"/>
-          </p:nvPr>
-        </p:nvSpPr>
-        <p:spPr/>
-      </p:sp>
-      <p:sp>
-        <p:nvSpPr>
-          <p:cNvPr id="3" name="Notes Placeholder 2"/>
-          <p:cNvSpPr>
-            <a:spLocks noGrp="1"/>
-          </p:cNvSpPr>
-          <p:nvPr>
-            <p:ph type="body" idx="3" sz="quarter"/>
-          </p:nvPr>
-        </p:nvSpPr>
-        <p:spPr/>
-        <p:txBody>
-          <a:bodyPr/>
-          <a:lstStyle/>
-          <a:p>
-            <a:r>
-              <a:t>≈ 15 s. Des années 1990 à 2011, l'apprentissage automatique s'impose, souvent sans que le grand public le sache.</a:t>
-            </a:r>
-          </a:p>
-        </p:txBody>
-      </p:sp>
-      <p:sp>
-        <p:nvSpPr>
-          <p:cNvPr id="4" name="Slide Number Placeholder 3"/>
-          <p:cNvSpPr>
-            <a:spLocks noGrp="1"/>
-          </p:cNvSpPr>
-          <p:nvPr>
-            <p:ph type="sldNum" idx="5" sz="quarter"/>
-          </p:nvPr>
-        </p:nvSpPr>
-        <p:spPr/>
-      </p:sp>
-    </p:spTree>
-  </p:cSld>
-  <p:clrMapOvr>
-    <a:masterClrMapping/>
-  </p:clrMapOvr>
-</p:notes>
-</file>
-
-<file path=ppt/notesSlides/notesSlide18.xml><?xml version="1.0" encoding="utf-8"?>
-<p:notes xmlns:a="http://schemas.openxmlformats.org/drawingml/2006/main" xmlns:p="http://schemas.openxmlformats.org/presentationml/2006/main" xmlns:r="http://schemas.openxmlformats.org/officeDocument/2006/relationships">
-  <p:cSld>
-    <p:spTree>
-      <p:nvGrpSpPr>
-        <p:cNvPr id="1" name=""/>
-        <p:cNvGrpSpPr/>
-        <p:nvPr/>
-      </p:nvGrpSpPr>
-      <p:grpSpPr>
-        <a:xfrm>
-          <a:off x="0" y="0"/>
-          <a:ext cx="0" cy="0"/>
-          <a:chOff x="0" y="0"/>
-          <a:chExt cx="0" cy="0"/>
-        </a:xfrm>
-      </p:grpSpPr>
-      <p:sp>
-        <p:nvSpPr>
-          <p:cNvPr id="2" name="Slide Image Placeholder 1"/>
-          <p:cNvSpPr>
-            <a:spLocks noGrp="1"/>
-          </p:cNvSpPr>
-          <p:nvPr>
-            <p:ph type="sldImg" idx="2"/>
-          </p:nvPr>
-        </p:nvSpPr>
-        <p:spPr/>
-      </p:sp>
-      <p:sp>
-        <p:nvSpPr>
-          <p:cNvPr id="3" name="Notes Placeholder 2"/>
-          <p:cNvSpPr>
-            <a:spLocks noGrp="1"/>
-          </p:cNvSpPr>
-          <p:nvPr>
-            <p:ph type="body" idx="3" sz="quarter"/>
-          </p:nvPr>
-        </p:nvSpPr>
-        <p:spPr/>
-        <p:txBody>
-          <a:bodyPr/>
-          <a:lstStyle/>
-          <a:p>
-            <a:r>
-              <a:t>≈ 2 min 30.</a:t>
-            </a:r>
-          </a:p>
-          <a:p/>
-          <a:p>
-            <a:r>
-              <a:t>1986 : la rétro-propagation du gradient permet enfin d'entraîner des réseaux à plusieurs couches (la réponse au problème du XOR de 1969). Geoffrey Hinton recevra le prix Nobel de physique en 2024 avec John Hopfield pour ces travaux fondateurs.</a:t>
-            </a:r>
-          </a:p>
-          <a:p/>
-          <a:p>
-            <a:r>
-              <a:t>LeNet : Yann LeCun, chercheur français, crée les réseaux convolutifs, ancêtres des modèles de vision actuels. Il recevra le prix Turing en 2018 avec Hinton et Bengio.</a:t>
-            </a:r>
-          </a:p>
-          <a:p/>
-          <a:p>
-            <a:r>
-              <a:t>Années 1990-2000 : les méthodes « statistiques » (SVM, arbres, forêts aléatoires, boosting) dominent, car les réseaux de neurones restent difficiles à entraîner faute de données et de puissance.</a:t>
-            </a:r>
-          </a:p>
-          <a:p/>
-          <a:p>
-            <a:r>
-              <a:t>Netflix Prize : exemple parfait de problème de recommandation ; la solution gagnante combinait des centaines de modèles.</a:t>
-            </a:r>
-          </a:p>
-        </p:txBody>
-      </p:sp>
-      <p:sp>
-        <p:nvSpPr>
-          <p:cNvPr id="4" name="Slide Number Placeholder 3"/>
-          <p:cNvSpPr>
-            <a:spLocks noGrp="1"/>
-          </p:cNvSpPr>
-          <p:nvPr>
-            <p:ph type="sldNum" idx="5" sz="quarter"/>
-          </p:nvPr>
-        </p:nvSpPr>
-        <p:spPr/>
-      </p:sp>
-    </p:spTree>
-  </p:cSld>
-  <p:clrMapOvr>
-    <a:masterClrMapping/>
-  </p:clrMapOvr>
-</p:notes>
-</file>
-
-<file path=ppt/notesSlides/notesSlide19.xml><?xml version="1.0" encoding="utf-8"?>
-<p:notes xmlns:a="http://schemas.openxmlformats.org/drawingml/2006/main" xmlns:p="http://schemas.openxmlformats.org/presentationml/2006/main" xmlns:r="http://schemas.openxmlformats.org/officeDocument/2006/relationships">
-  <p:cSld>
-    <p:spTree>
-      <p:nvGrpSpPr>
-        <p:cNvPr id="1" name=""/>
-        <p:cNvGrpSpPr/>
-        <p:nvPr/>
-      </p:nvGrpSpPr>
-      <p:grpSpPr>
-        <a:xfrm>
-          <a:off x="0" y="0"/>
-          <a:ext cx="0" cy="0"/>
-          <a:chOff x="0" y="0"/>
-          <a:chExt cx="0" cy="0"/>
-        </a:xfrm>
-      </p:grpSpPr>
-      <p:sp>
-        <p:nvSpPr>
-          <p:cNvPr id="2" name="Slide Image Placeholder 1"/>
-          <p:cNvSpPr>
-            <a:spLocks noGrp="1"/>
-          </p:cNvSpPr>
-          <p:nvPr>
-            <p:ph type="sldImg" idx="2"/>
-          </p:nvPr>
-        </p:nvSpPr>
-        <p:spPr/>
-      </p:sp>
-      <p:sp>
-        <p:nvSpPr>
-          <p:cNvPr id="3" name="Notes Placeholder 2"/>
-          <p:cNvSpPr>
-            <a:spLocks noGrp="1"/>
-          </p:cNvSpPr>
-          <p:nvPr>
-            <p:ph type="body" idx="3" sz="quarter"/>
-          </p:nvPr>
-        </p:nvSpPr>
-        <p:spPr/>
-        <p:txBody>
-          <a:bodyPr/>
-          <a:lstStyle/>
-          <a:p>
-            <a:r>
-              <a:t>≈ 15 s. Les réseaux de neurones, marginalisés pendant vingt ans, reviennent au premier plan à partir de 2012.</a:t>
-            </a:r>
-          </a:p>
-        </p:txBody>
-      </p:sp>
-      <p:sp>
-        <p:nvSpPr>
-          <p:cNvPr id="4" name="Slide Number Placeholder 3"/>
-          <p:cNvSpPr>
-            <a:spLocks noGrp="1"/>
-          </p:cNvSpPr>
-          <p:nvPr>
-            <p:ph type="sldNum" idx="5" sz="quarter"/>
-          </p:nvPr>
-        </p:nvSpPr>
-        <p:spPr/>
-      </p:sp>
-    </p:spTree>
-  </p:cSld>
-  <p:clrMapOvr>
-    <a:masterClrMapping/>
-  </p:clrMapOvr>
-</p:notes>
-</file>
-
-<file path=ppt/notesSlides/notesSlide2.xml><?xml version="1.0" encoding="utf-8"?>
-<p:notes xmlns:a="http://schemas.openxmlformats.org/drawingml/2006/main" xmlns:p="http://schemas.openxmlformats.org/presentationml/2006/main" xmlns:r="http://schemas.openxmlformats.org/officeDocument/2006/relationships">
-  <p:cSld>
-    <p:spTree>
-      <p:nvGrpSpPr>
-        <p:cNvPr id="1" name=""/>
-        <p:cNvGrpSpPr/>
-        <p:nvPr/>
-      </p:nvGrpSpPr>
-      <p:grpSpPr>
-        <a:xfrm>
-          <a:off x="0" y="0"/>
-          <a:ext cx="0" cy="0"/>
-          <a:chOff x="0" y="0"/>
-          <a:chExt cx="0" cy="0"/>
-        </a:xfrm>
-      </p:grpSpPr>
-      <p:sp>
-        <p:nvSpPr>
-          <p:cNvPr id="2" name="Slide Image Placeholder 1"/>
-          <p:cNvSpPr>
-            <a:spLocks noGrp="1"/>
-          </p:cNvSpPr>
-          <p:nvPr>
-            <p:ph type="sldImg" idx="2"/>
-          </p:nvPr>
-        </p:nvSpPr>
-        <p:spPr/>
-      </p:sp>
-      <p:sp>
-        <p:nvSpPr>
-          <p:cNvPr id="3" name="Notes Placeholder 2"/>
-          <p:cNvSpPr>
-            <a:spLocks noGrp="1"/>
-          </p:cNvSpPr>
-          <p:nvPr>
-            <p:ph type="body" idx="3" sz="quarter"/>
-          </p:nvPr>
-        </p:nvSpPr>
-        <p:spPr/>
-        <p:txBody>
-          <a:bodyPr/>
-          <a:lstStyle/>
-          <a:p>
-            <a:r>
-              <a:t>≈ 1 min.</a:t>
-            </a:r>
-          </a:p>
-          <a:p/>
-          <a:p>
-            <a:r>
-              <a:t>Annoncer le plan : six époques, entrecoupées de deux « hivers de l'IA » (périodes de désillusion). Insister sur le fil rouge : l'histoire de l'IA est largement celle du passage de règles écrites à la main à des modèles qui apprennent à partir de données. C'est exactement ce que les étudiants pratiqueront en TP.</a:t>
-            </a:r>
-          </a:p>
-        </p:txBody>
-      </p:sp>
-      <p:sp>
-        <p:nvSpPr>
-          <p:cNvPr id="4" name="Slide Number Placeholder 3"/>
-          <p:cNvSpPr>
-            <a:spLocks noGrp="1"/>
-          </p:cNvSpPr>
-          <p:nvPr>
-            <p:ph type="sldNum" idx="5" sz="quarter"/>
-          </p:nvPr>
-        </p:nvSpPr>
-        <p:spPr/>
-      </p:sp>
-    </p:spTree>
-  </p:cSld>
-  <p:clrMapOvr>
-    <a:masterClrMapping/>
-  </p:clrMapOvr>
-</p:notes>
-</file>
-
-<file path=ppt/notesSlides/notesSlide20.xml><?xml version="1.0" encoding="utf-8"?>
-<p:notes xmlns:a="http://schemas.openxmlformats.org/drawingml/2006/main" xmlns:p="http://schemas.openxmlformats.org/presentationml/2006/main" xmlns:r="http://schemas.openxmlformats.org/officeDocument/2006/relationships">
-  <p:cSld>
-    <p:spTree>
-      <p:nvGrpSpPr>
-        <p:cNvPr id="1" name=""/>
-        <p:cNvGrpSpPr/>
-        <p:nvPr/>
-      </p:nvGrpSpPr>
-      <p:grpSpPr>
-        <a:xfrm>
-          <a:off x="0" y="0"/>
-          <a:ext cx="0" cy="0"/>
-          <a:chOff x="0" y="0"/>
-          <a:chExt cx="0" cy="0"/>
-        </a:xfrm>
-      </p:grpSpPr>
-      <p:sp>
-        <p:nvSpPr>
-          <p:cNvPr id="2" name="Slide Image Placeholder 1"/>
-          <p:cNvSpPr>
-            <a:spLocks noGrp="1"/>
-          </p:cNvSpPr>
-          <p:nvPr>
-            <p:ph type="sldImg" idx="2"/>
-          </p:nvPr>
-        </p:nvSpPr>
-        <p:spPr/>
-      </p:sp>
-      <p:sp>
-        <p:nvSpPr>
-          <p:cNvPr id="3" name="Notes Placeholder 2"/>
-          <p:cNvSpPr>
-            <a:spLocks noGrp="1"/>
-          </p:cNvSpPr>
-          <p:nvPr>
-            <p:ph type="body" idx="3" sz="quarter"/>
-          </p:nvPr>
-        </p:nvSpPr>
-        <p:spPr/>
-        <p:txBody>
-          <a:bodyPr/>
-          <a:lstStyle/>
-          <a:p>
-            <a:r>
-              <a:t>≈ 2 min.</a:t>
-            </a:r>
-          </a:p>
-          <a:p/>
-          <a:p>
-            <a:r>
-              <a:t>Les idées des réseaux de neurones existaient depuis les années 1980. Ce qui change vers 2010 :</a:t>
-            </a:r>
-          </a:p>
-          <a:p>
-            <a:r>
-              <a:t>1. Les données : ImageNet, lancé par Fei-Fei Li (Stanford), rassemble plus de 14 millions d'images annotées par des milliers de travailleurs en ligne.</a:t>
-            </a:r>
-          </a:p>
-          <a:p>
-            <a:r>
-              <a:t>2. Le calcul : les GPU, développés pour le jeu vidéo (calculs matriciels massivement parallèles), accélèrent l'entraînement d'un facteur 10 à 100. AlexNet a été entraîné en environ une semaine sur deux cartes graphiques grand public.</a:t>
-            </a:r>
-          </a:p>
-          <a:p>
-            <a:r>
-              <a:t>3. Les algorithmes : fonctions d'activation ReLU, dropout, meilleures initialisations…</a:t>
-            </a:r>
-          </a:p>
-          <a:p/>
-          <a:p>
-            <a:r>
-              <a:t>Message : les progrès de l'IA dépendent autant des données et du matériel que des idées.</a:t>
-            </a:r>
-          </a:p>
-        </p:txBody>
-      </p:sp>
-      <p:sp>
-        <p:nvSpPr>
-          <p:cNvPr id="4" name="Slide Number Placeholder 3"/>
-          <p:cNvSpPr>
-            <a:spLocks noGrp="1"/>
-          </p:cNvSpPr>
-          <p:nvPr>
-            <p:ph type="sldNum" idx="5" sz="quarter"/>
-          </p:nvPr>
-        </p:nvSpPr>
-        <p:spPr/>
-      </p:sp>
-    </p:spTree>
-  </p:cSld>
-  <p:clrMapOvr>
-    <a:masterClrMapping/>
-  </p:clrMapOvr>
-</p:notes>
-</file>
-
-<file path=ppt/notesSlides/notesSlide21.xml><?xml version="1.0" encoding="utf-8"?>
-<p:notes xmlns:a="http://schemas.openxmlformats.org/drawingml/2006/main" xmlns:p="http://schemas.openxmlformats.org/presentationml/2006/main" xmlns:r="http://schemas.openxmlformats.org/officeDocument/2006/relationships">
-  <p:cSld>
-    <p:spTree>
-      <p:nvGrpSpPr>
-        <p:cNvPr id="1" name=""/>
-        <p:cNvGrpSpPr/>
-        <p:nvPr/>
-      </p:nvGrpSpPr>
-      <p:grpSpPr>
-        <a:xfrm>
-          <a:off x="0" y="0"/>
-          <a:ext cx="0" cy="0"/>
-          <a:chOff x="0" y="0"/>
-          <a:chExt cx="0" cy="0"/>
-        </a:xfrm>
-      </p:grpSpPr>
-      <p:sp>
-        <p:nvSpPr>
-          <p:cNvPr id="2" name="Slide Image Placeholder 1"/>
-          <p:cNvSpPr>
-            <a:spLocks noGrp="1"/>
-          </p:cNvSpPr>
-          <p:nvPr>
-            <p:ph type="sldImg" idx="2"/>
-          </p:nvPr>
-        </p:nvSpPr>
-        <p:spPr/>
-      </p:sp>
-      <p:sp>
-        <p:nvSpPr>
-          <p:cNvPr id="3" name="Notes Placeholder 2"/>
-          <p:cNvSpPr>
-            <a:spLocks noGrp="1"/>
-          </p:cNvSpPr>
-          <p:nvPr>
-            <p:ph type="body" idx="3" sz="quarter"/>
-          </p:nvPr>
-        </p:nvSpPr>
-        <p:spPr/>
-        <p:txBody>
-          <a:bodyPr/>
-          <a:lstStyle/>
-          <a:p>
-            <a:r>
-              <a:t>≈ 2 min.</a:t>
-            </a:r>
-          </a:p>
-          <a:p/>
-          <a:p>
-            <a:r>
-              <a:t>Le graphique montre le taux d'erreur « top-5 » du vainqueur de chaque édition du concours ILSVRC (ImageNet Large Scale Visual Recognition Challenge). Jusqu'en 2011, les progrès sont lents, avec des méthodes de vision « à la main ». En 2012, AlexNet passe à 16,4 % contre 25,8 % l'année précédente.</a:t>
-            </a:r>
-          </a:p>
-          <a:p/>
-          <a:p>
-            <a:r>
-              <a:t>Le chiffre de 5 % pour l'humain vient d'une expérience d'Andrej Karpathy (2014) : c'est une estimation sur une tâche particulière, pas une preuve que la machine « voit mieux » que nous en général.</a:t>
-            </a:r>
-          </a:p>
-          <a:p/>
-          <a:p>
-            <a:r>
-              <a:t>Ilya Sutskever, co-auteur d'AlexNet, co-fondera OpenAI trois ans plus tard.</a:t>
-            </a:r>
-          </a:p>
-        </p:txBody>
-      </p:sp>
-      <p:sp>
-        <p:nvSpPr>
-          <p:cNvPr id="4" name="Slide Number Placeholder 3"/>
-          <p:cNvSpPr>
-            <a:spLocks noGrp="1"/>
-          </p:cNvSpPr>
-          <p:nvPr>
-            <p:ph type="sldNum" idx="5" sz="quarter"/>
-          </p:nvPr>
-        </p:nvSpPr>
-        <p:spPr/>
-      </p:sp>
-    </p:spTree>
-  </p:cSld>
-  <p:clrMapOvr>
-    <a:masterClrMapping/>
-  </p:clrMapOvr>
-</p:notes>
-</file>
-
-<file path=ppt/notesSlides/notesSlide22.xml><?xml version="1.0" encoding="utf-8"?>
-<p:notes xmlns:a="http://schemas.openxmlformats.org/drawingml/2006/main" xmlns:p="http://schemas.openxmlformats.org/presentationml/2006/main" xmlns:r="http://schemas.openxmlformats.org/officeDocument/2006/relationships">
-  <p:cSld>
-    <p:spTree>
-      <p:nvGrpSpPr>
-        <p:cNvPr id="1" name=""/>
-        <p:cNvGrpSpPr/>
-        <p:nvPr/>
-      </p:nvGrpSpPr>
-      <p:grpSpPr>
-        <a:xfrm>
-          <a:off x="0" y="0"/>
-          <a:ext cx="0" cy="0"/>
-          <a:chOff x="0" y="0"/>
-          <a:chExt cx="0" cy="0"/>
-        </a:xfrm>
-      </p:grpSpPr>
-      <p:sp>
-        <p:nvSpPr>
-          <p:cNvPr id="2" name="Slide Image Placeholder 1"/>
-          <p:cNvSpPr>
-            <a:spLocks noGrp="1"/>
-          </p:cNvSpPr>
-          <p:nvPr>
-            <p:ph type="sldImg" idx="2"/>
-          </p:nvPr>
-        </p:nvSpPr>
-        <p:spPr/>
-      </p:sp>
-      <p:sp>
-        <p:nvSpPr>
-          <p:cNvPr id="3" name="Notes Placeholder 2"/>
-          <p:cNvSpPr>
-            <a:spLocks noGrp="1"/>
-          </p:cNvSpPr>
-          <p:nvPr>
-            <p:ph type="body" idx="3" sz="quarter"/>
-          </p:nvPr>
-        </p:nvSpPr>
-        <p:spPr/>
-        <p:txBody>
-          <a:bodyPr/>
-          <a:lstStyle/>
-          <a:p>
-            <a:r>
-              <a:t>≈ 2 min.</a:t>
-            </a:r>
-          </a:p>
-          <a:p/>
-          <a:p>
-            <a:r>
-              <a:t>« Profond » fait simplement référence au nombre de couches du réseau.</a:t>
-            </a:r>
-          </a:p>
-          <a:p/>
-          <a:p>
-            <a:r>
-              <a:t>Avant le deep learning, les experts en vision concevaient à la main des « descripteurs » (détecteurs de coins, de textures…). Le deep learning apprend lui-même ces descripteurs : c'est l'apprentissage de représentations. On retrouve le fil rouge : on remplace ce qui était écrit à la main par ce qui est appris.</a:t>
-            </a:r>
-          </a:p>
-          <a:p/>
-          <a:p>
-            <a:r>
-              <a:t>La progression contours → formes → parties d'objets a été observée en visualisant les neurones de réseaux entraînés.</a:t>
-            </a:r>
-          </a:p>
-        </p:txBody>
-      </p:sp>
-      <p:sp>
-        <p:nvSpPr>
-          <p:cNvPr id="4" name="Slide Number Placeholder 3"/>
-          <p:cNvSpPr>
-            <a:spLocks noGrp="1"/>
-          </p:cNvSpPr>
-          <p:nvPr>
-            <p:ph type="sldNum" idx="5" sz="quarter"/>
-          </p:nvPr>
-        </p:nvSpPr>
-        <p:spPr/>
-      </p:sp>
-    </p:spTree>
-  </p:cSld>
-  <p:clrMapOvr>
-    <a:masterClrMapping/>
-  </p:clrMapOvr>
-</p:notes>
-</file>
-
-<file path=ppt/notesSlides/notesSlide23.xml><?xml version="1.0" encoding="utf-8"?>
-<p:notes xmlns:a="http://schemas.openxmlformats.org/drawingml/2006/main" xmlns:p="http://schemas.openxmlformats.org/presentationml/2006/main" xmlns:r="http://schemas.openxmlformats.org/officeDocument/2006/relationships">
-  <p:cSld>
-    <p:spTree>
-      <p:nvGrpSpPr>
-        <p:cNvPr id="1" name=""/>
-        <p:cNvGrpSpPr/>
-        <p:nvPr/>
-      </p:nvGrpSpPr>
-      <p:grpSpPr>
-        <a:xfrm>
-          <a:off x="0" y="0"/>
-          <a:ext cx="0" cy="0"/>
-          <a:chOff x="0" y="0"/>
-          <a:chExt cx="0" cy="0"/>
-        </a:xfrm>
-      </p:grpSpPr>
-      <p:sp>
-        <p:nvSpPr>
-          <p:cNvPr id="2" name="Slide Image Placeholder 1"/>
-          <p:cNvSpPr>
-            <a:spLocks noGrp="1"/>
-          </p:cNvSpPr>
-          <p:nvPr>
-            <p:ph type="sldImg" idx="2"/>
-          </p:nvPr>
-        </p:nvSpPr>
-        <p:spPr/>
-      </p:sp>
-      <p:sp>
-        <p:nvSpPr>
-          <p:cNvPr id="3" name="Notes Placeholder 2"/>
-          <p:cNvSpPr>
-            <a:spLocks noGrp="1"/>
-          </p:cNvSpPr>
-          <p:nvPr>
-            <p:ph type="body" idx="3" sz="quarter"/>
-          </p:nvPr>
-        </p:nvSpPr>
-        <p:spPr/>
-        <p:txBody>
-          <a:bodyPr/>
-          <a:lstStyle/>
-          <a:p>
-            <a:r>
-              <a:t>≈ 2 min 30.</a:t>
-            </a:r>
-          </a:p>
-          <a:p/>
-          <a:p>
-            <a:r>
-              <a:t>Deux victoires contre des champions du monde, mais deux philosophies opposées :</a:t>
-            </a:r>
-          </a:p>
-          <a:p>
-            <a:r>
-              <a:t>- Deep Blue est l'aboutissement de l'IA symbolique et de la puissance de calcul : une fonction d'évaluation écrite à la main et une recherche massive.</a:t>
-            </a:r>
-          </a:p>
-          <a:p>
-            <a:r>
-              <a:t>- AlphaGo combine réseaux de neurones profonds et apprentissage par renforcement (apprendre en jouant, en étant récompensé quand on gagne). Au go, le nombre de positions rend la force brute inenvisageable : il faut une forme d'« intuition » apprise.</a:t>
-            </a:r>
-          </a:p>
-          <a:p/>
-          <a:p>
-            <a:r>
-              <a:t>Le « coup 37 » de la deuxième partie contre Lee Sedol a stupéfié les commentateurs, qui l'ont d'abord pris pour une erreur. Son successeur, AlphaZero (2017), apprend uniquement en jouant contre lui-même, sans aucune partie humaine.</a:t>
-            </a:r>
-          </a:p>
-        </p:txBody>
-      </p:sp>
-      <p:sp>
-        <p:nvSpPr>
-          <p:cNvPr id="4" name="Slide Number Placeholder 3"/>
-          <p:cNvSpPr>
-            <a:spLocks noGrp="1"/>
-          </p:cNvSpPr>
-          <p:nvPr>
-            <p:ph type="sldNum" idx="5" sz="quarter"/>
-          </p:nvPr>
-        </p:nvSpPr>
-        <p:spPr/>
-      </p:sp>
-    </p:spTree>
-  </p:cSld>
-  <p:clrMapOvr>
-    <a:masterClrMapping/>
-  </p:clrMapOvr>
-</p:notes>
-</file>
-
-<file path=ppt/notesSlides/notesSlide24.xml><?xml version="1.0" encoding="utf-8"?>
-<p:notes xmlns:a="http://schemas.openxmlformats.org/drawingml/2006/main" xmlns:p="http://schemas.openxmlformats.org/presentationml/2006/main" xmlns:r="http://schemas.openxmlformats.org/officeDocument/2006/relationships">
-  <p:cSld>
-    <p:spTree>
-      <p:nvGrpSpPr>
-        <p:cNvPr id="1" name=""/>
-        <p:cNvGrpSpPr/>
-        <p:nvPr/>
-      </p:nvGrpSpPr>
-      <p:grpSpPr>
-        <a:xfrm>
-          <a:off x="0" y="0"/>
-          <a:ext cx="0" cy="0"/>
-          <a:chOff x="0" y="0"/>
-          <a:chExt cx="0" cy="0"/>
-        </a:xfrm>
-      </p:grpSpPr>
-      <p:sp>
-        <p:nvSpPr>
-          <p:cNvPr id="2" name="Slide Image Placeholder 1"/>
-          <p:cNvSpPr>
-            <a:spLocks noGrp="1"/>
-          </p:cNvSpPr>
-          <p:nvPr>
-            <p:ph type="sldImg" idx="2"/>
-          </p:nvPr>
-        </p:nvSpPr>
-        <p:spPr/>
-      </p:sp>
-      <p:sp>
-        <p:nvSpPr>
-          <p:cNvPr id="3" name="Notes Placeholder 2"/>
-          <p:cNvSpPr>
-            <a:spLocks noGrp="1"/>
-          </p:cNvSpPr>
-          <p:nvPr>
-            <p:ph type="body" idx="3" sz="quarter"/>
-          </p:nvPr>
-        </p:nvSpPr>
-        <p:spPr/>
-        <p:txBody>
-          <a:bodyPr/>
-          <a:lstStyle/>
-          <a:p>
-            <a:r>
-              <a:t>≈ 2 min.</a:t>
-            </a:r>
-          </a:p>
-          <a:p/>
-          <a:p>
-            <a:r>
-              <a:t>Passer rapidement : l'idée est de montrer l'étendue des applications en quelques années.</a:t>
-            </a:r>
-          </a:p>
-          <a:p/>
-          <a:p>
-            <a:r>
-              <a:t>AlphaFold (DeepMind) : la structure 3D d'une protéine détermine sa fonction ; la déterminer expérimentalement pouvait prendre des années. Demis Hassabis et John Jumper ont reçu le prix Nobel de chimie 2024 (avec David Baker, pour la conception de protéines).</a:t>
-            </a:r>
-          </a:p>
-          <a:p/>
-          <a:p>
-            <a:r>
-              <a:t>Deepfakes : premier signe que la puissance de ces modèles pose des questions éthiques et sociétales, thème que l'on retrouvera à la fin.</a:t>
-            </a:r>
-          </a:p>
-        </p:txBody>
-      </p:sp>
-      <p:sp>
-        <p:nvSpPr>
-          <p:cNvPr id="4" name="Slide Number Placeholder 3"/>
-          <p:cNvSpPr>
-            <a:spLocks noGrp="1"/>
-          </p:cNvSpPr>
-          <p:nvPr>
-            <p:ph type="sldNum" idx="5" sz="quarter"/>
-          </p:nvPr>
-        </p:nvSpPr>
-        <p:spPr/>
-      </p:sp>
-    </p:spTree>
-  </p:cSld>
-  <p:clrMapOvr>
-    <a:masterClrMapping/>
-  </p:clrMapOvr>
-</p:notes>
-</file>
-
-<file path=ppt/notesSlides/notesSlide25.xml><?xml version="1.0" encoding="utf-8"?>
-<p:notes xmlns:a="http://schemas.openxmlformats.org/drawingml/2006/main" xmlns:p="http://schemas.openxmlformats.org/presentationml/2006/main" xmlns:r="http://schemas.openxmlformats.org/officeDocument/2006/relationships">
-  <p:cSld>
-    <p:spTree>
-      <p:nvGrpSpPr>
-        <p:cNvPr id="1" name=""/>
-        <p:cNvGrpSpPr/>
-        <p:nvPr/>
-      </p:nvGrpSpPr>
-      <p:grpSpPr>
-        <a:xfrm>
-          <a:off x="0" y="0"/>
-          <a:ext cx="0" cy="0"/>
-          <a:chOff x="0" y="0"/>
-          <a:chExt cx="0" cy="0"/>
-        </a:xfrm>
-      </p:grpSpPr>
-      <p:sp>
-        <p:nvSpPr>
-          <p:cNvPr id="2" name="Slide Image Placeholder 1"/>
-          <p:cNvSpPr>
-            <a:spLocks noGrp="1"/>
-          </p:cNvSpPr>
-          <p:nvPr>
-            <p:ph type="sldImg" idx="2"/>
-          </p:nvPr>
-        </p:nvSpPr>
-        <p:spPr/>
-      </p:sp>
-      <p:sp>
-        <p:nvSpPr>
-          <p:cNvPr id="3" name="Notes Placeholder 2"/>
-          <p:cNvSpPr>
-            <a:spLocks noGrp="1"/>
-          </p:cNvSpPr>
-          <p:nvPr>
-            <p:ph type="body" idx="3" sz="quarter"/>
-          </p:nvPr>
-        </p:nvSpPr>
-        <p:spPr/>
-        <p:txBody>
-          <a:bodyPr/>
-          <a:lstStyle/>
-          <a:p>
-            <a:r>
-              <a:t>≈ 15 s. Depuis 2017, les modèles ne se contentent plus de reconnaître : ils génèrent du texte, des images, du son, du code.</a:t>
-            </a:r>
-          </a:p>
-        </p:txBody>
-      </p:sp>
-      <p:sp>
-        <p:nvSpPr>
-          <p:cNvPr id="4" name="Slide Number Placeholder 3"/>
-          <p:cNvSpPr>
-            <a:spLocks noGrp="1"/>
-          </p:cNvSpPr>
-          <p:nvPr>
-            <p:ph type="sldNum" idx="5" sz="quarter"/>
-          </p:nvPr>
-        </p:nvSpPr>
-        <p:spPr/>
-      </p:sp>
-    </p:spTree>
-  </p:cSld>
-  <p:clrMapOvr>
-    <a:masterClrMapping/>
-  </p:clrMapOvr>
-</p:notes>
-</file>
-
-<file path=ppt/notesSlides/notesSlide26.xml><?xml version="1.0" encoding="utf-8"?>
-<p:notes xmlns:a="http://schemas.openxmlformats.org/drawingml/2006/main" xmlns:p="http://schemas.openxmlformats.org/presentationml/2006/main" xmlns:r="http://schemas.openxmlformats.org/officeDocument/2006/relationships">
-  <p:cSld>
-    <p:spTree>
-      <p:nvGrpSpPr>
-        <p:cNvPr id="1" name=""/>
-        <p:cNvGrpSpPr/>
-        <p:nvPr/>
-      </p:nvGrpSpPr>
-      <p:grpSpPr>
-        <a:xfrm>
-          <a:off x="0" y="0"/>
-          <a:ext cx="0" cy="0"/>
-          <a:chOff x="0" y="0"/>
-          <a:chExt cx="0" cy="0"/>
-        </a:xfrm>
-      </p:grpSpPr>
-      <p:sp>
-        <p:nvSpPr>
-          <p:cNvPr id="2" name="Slide Image Placeholder 1"/>
-          <p:cNvSpPr>
-            <a:spLocks noGrp="1"/>
-          </p:cNvSpPr>
-          <p:nvPr>
-            <p:ph type="sldImg" idx="2"/>
-          </p:nvPr>
-        </p:nvSpPr>
-        <p:spPr/>
-      </p:sp>
-      <p:sp>
-        <p:nvSpPr>
-          <p:cNvPr id="3" name="Notes Placeholder 2"/>
-          <p:cNvSpPr>
-            <a:spLocks noGrp="1"/>
-          </p:cNvSpPr>
-          <p:nvPr>
-            <p:ph type="body" idx="3" sz="quarter"/>
-          </p:nvPr>
-        </p:nvSpPr>
-        <p:spPr/>
-        <p:txBody>
-          <a:bodyPr/>
-          <a:lstStyle/>
-          <a:p>
-            <a:r>
-              <a:t>≈ 3 min — deuxième diapositive clé.</a:t>
-            </a:r>
-          </a:p>
-          <a:p/>
-          <a:p>
-            <a:r>
-              <a:t>Démystifier ChatGPT : c'est un modèle qui, étant donné un début de texte, calcule la probabilité de chaque mot possible pour la suite. En pratique, il travaille sur des « tokens » (morceaux de mots) plutôt que sur des mots entiers.</a:t>
-            </a:r>
-          </a:p>
-          <a:p/>
-          <a:p>
-            <a:r>
-              <a:t>L'architecture sous-jacente est le Transformer, inventé chez Google en 2017 (article « Attention Is All You Need ») : son mécanisme d'« attention » permet de tenir compte de tout le contexte, même éloigné.</a:t>
-            </a:r>
-          </a:p>
-          <a:p/>
-          <a:p>
-            <a:r>
-              <a:t>L'affinage par retour humain (RLHF) transforme un simple « compléteur de texte » en assistant conversationnel.</a:t>
-            </a:r>
-          </a:p>
-          <a:p/>
-          <a:p>
-            <a:r>
-              <a:t>Conséquence importante : comme le modèle produit du texte plausible, il peut affirmer des choses fausses avec aplomb. On parle d'« hallucinations ».</a:t>
-            </a:r>
-          </a:p>
-        </p:txBody>
-      </p:sp>
-      <p:sp>
-        <p:nvSpPr>
-          <p:cNvPr id="4" name="Slide Number Placeholder 3"/>
-          <p:cNvSpPr>
-            <a:spLocks noGrp="1"/>
-          </p:cNvSpPr>
-          <p:nvPr>
-            <p:ph type="sldNum" idx="5" sz="quarter"/>
-          </p:nvPr>
-        </p:nvSpPr>
-        <p:spPr/>
-      </p:sp>
-    </p:spTree>
-  </p:cSld>
-  <p:clrMapOvr>
-    <a:masterClrMapping/>
-  </p:clrMapOvr>
-</p:notes>
-</file>
-
-<file path=ppt/notesSlides/notesSlide27.xml><?xml version="1.0" encoding="utf-8"?>
-<p:notes xmlns:a="http://schemas.openxmlformats.org/drawingml/2006/main" xmlns:p="http://schemas.openxmlformats.org/presentationml/2006/main" xmlns:r="http://schemas.openxmlformats.org/officeDocument/2006/relationships">
-  <p:cSld>
-    <p:spTree>
-      <p:nvGrpSpPr>
-        <p:cNvPr id="1" name=""/>
-        <p:cNvGrpSpPr/>
-        <p:nvPr/>
-      </p:nvGrpSpPr>
-      <p:grpSpPr>
-        <a:xfrm>
-          <a:off x="0" y="0"/>
-          <a:ext cx="0" cy="0"/>
-          <a:chOff x="0" y="0"/>
-          <a:chExt cx="0" cy="0"/>
-        </a:xfrm>
-      </p:grpSpPr>
-      <p:sp>
-        <p:nvSpPr>
-          <p:cNvPr id="2" name="Slide Image Placeholder 1"/>
-          <p:cNvSpPr>
-            <a:spLocks noGrp="1"/>
-          </p:cNvSpPr>
-          <p:nvPr>
-            <p:ph type="sldImg" idx="2"/>
-          </p:nvPr>
-        </p:nvSpPr>
-        <p:spPr/>
-      </p:sp>
-      <p:sp>
-        <p:nvSpPr>
-          <p:cNvPr id="3" name="Notes Placeholder 2"/>
-          <p:cNvSpPr>
-            <a:spLocks noGrp="1"/>
-          </p:cNvSpPr>
-          <p:nvPr>
-            <p:ph type="body" idx="3" sz="quarter"/>
-          </p:nvPr>
-        </p:nvSpPr>
-        <p:spPr/>
-        <p:txBody>
-          <a:bodyPr/>
-          <a:lstStyle/>
-          <a:p>
-            <a:r>
-              <a:t>≈ 2 min 30.</a:t>
-            </a:r>
-          </a:p>
-          <a:p/>
-          <a:p>
-            <a:r>
-              <a:t>Passer en revue la frise en insistant sur l'accélération :</a:t>
-            </a:r>
-          </a:p>
-          <a:p>
-            <a:r>
-              <a:t>- 2017 : le Transformer, publié par une équipe de Google, sera repris par tous.</a:t>
-            </a:r>
-          </a:p>
-          <a:p>
-            <a:r>
-              <a:t>- GPT = Generative Pre-trained Transformer. Le nombre de paramètres (les poids des neurones) explose : 117 millions pour GPT-1 (2018), 175 milliards pour GPT-3 (2020).</a:t>
-            </a:r>
-          </a:p>
-          <a:p>
-            <a:r>
-              <a:t>- 2022 : l'IA générative d'images devient accessible à tous ; ChatGPT, fondé sur GPT-3.5, provoque un choc mondial.</a:t>
-            </a:r>
-          </a:p>
-          <a:p>
-            <a:r>
-              <a:t>- 2023 : de nombreux acteurs entrent dans la course, y compris des modèles « ouverts » (Llama, Mistral). Mistral AI est une start-up française fondée en 2023.</a:t>
-            </a:r>
-          </a:p>
-          <a:p>
-            <a:r>
-              <a:t>- 2024-2025 : les modèles deviennent multimodaux, capables de raisonner plus longuement et d'agir (agents).</a:t>
-            </a:r>
-          </a:p>
-          <a:p/>
-          <a:p>
-            <a:r>
-              <a:t>Mentionner les prix Nobel 2024 (physique : Hopfield et Hinton ; chimie : Hassabis, Jumper et Baker) comme signe de la reconnaissance scientifique du domaine.</a:t>
-            </a:r>
-          </a:p>
-        </p:txBody>
-      </p:sp>
-      <p:sp>
-        <p:nvSpPr>
-          <p:cNvPr id="4" name="Slide Number Placeholder 3"/>
-          <p:cNvSpPr>
-            <a:spLocks noGrp="1"/>
-          </p:cNvSpPr>
-          <p:nvPr>
-            <p:ph type="sldNum" idx="5" sz="quarter"/>
-          </p:nvPr>
-        </p:nvSpPr>
-        <p:spPr/>
-      </p:sp>
-    </p:spTree>
-  </p:cSld>
-  <p:clrMapOvr>
-    <a:masterClrMapping/>
-  </p:clrMapOvr>
-</p:notes>
-</file>
-
-<file path=ppt/notesSlides/notesSlide28.xml><?xml version="1.0" encoding="utf-8"?>
-<p:notes xmlns:a="http://schemas.openxmlformats.org/drawingml/2006/main" xmlns:p="http://schemas.openxmlformats.org/presentationml/2006/main" xmlns:r="http://schemas.openxmlformats.org/officeDocument/2006/relationships">
-  <p:cSld>
-    <p:spTree>
-      <p:nvGrpSpPr>
-        <p:cNvPr id="1" name=""/>
-        <p:cNvGrpSpPr/>
-        <p:nvPr/>
-      </p:nvGrpSpPr>
-      <p:grpSpPr>
-        <a:xfrm>
-          <a:off x="0" y="0"/>
-          <a:ext cx="0" cy="0"/>
-          <a:chOff x="0" y="0"/>
-          <a:chExt cx="0" cy="0"/>
-        </a:xfrm>
-      </p:grpSpPr>
-      <p:sp>
-        <p:nvSpPr>
-          <p:cNvPr id="2" name="Slide Image Placeholder 1"/>
-          <p:cNvSpPr>
-            <a:spLocks noGrp="1"/>
-          </p:cNvSpPr>
-          <p:nvPr>
-            <p:ph type="sldImg" idx="2"/>
-          </p:nvPr>
-        </p:nvSpPr>
-        <p:spPr/>
-      </p:sp>
-      <p:sp>
-        <p:nvSpPr>
-          <p:cNvPr id="3" name="Notes Placeholder 2"/>
-          <p:cNvSpPr>
-            <a:spLocks noGrp="1"/>
-          </p:cNvSpPr>
-          <p:nvPr>
-            <p:ph type="body" idx="3" sz="quarter"/>
-          </p:nvPr>
-        </p:nvSpPr>
-        <p:spPr/>
-        <p:txBody>
-          <a:bodyPr/>
-          <a:lstStyle/>
-          <a:p>
-            <a:r>
-              <a:t>≈ 1 min.</a:t>
-            </a:r>
-          </a:p>
-          <a:p/>
-          <a:p>
-            <a:r>
-              <a:t>ChatGPT est l'application grand public qui s'est diffusée le plus vite de l'histoire (jusqu'alors). La raison principale : l'interface. On converse en langage naturel, sans rien installer ni programmer.</a:t>
-            </a:r>
-          </a:p>
-          <a:p/>
-          <a:p>
-            <a:r>
-              <a:t>Question à la salle : qui utilise un assistant conversationnel pour ses études ? Pour quoi faire ? Bonne transition vers les enjeux.</a:t>
-            </a:r>
-          </a:p>
-        </p:txBody>
-      </p:sp>
-      <p:sp>
-        <p:nvSpPr>
-          <p:cNvPr id="4" name="Slide Number Placeholder 3"/>
-          <p:cNvSpPr>
-            <a:spLocks noGrp="1"/>
-          </p:cNvSpPr>
-          <p:nvPr>
-            <p:ph type="sldNum" idx="5" sz="quarter"/>
-          </p:nvPr>
-        </p:nvSpPr>
-        <p:spPr/>
-      </p:sp>
-    </p:spTree>
-  </p:cSld>
-  <p:clrMapOvr>
-    <a:masterClrMapping/>
-  </p:clrMapOvr>
-</p:notes>
-</file>
-
-<file path=ppt/notesSlides/notesSlide29.xml><?xml version="1.0" encoding="utf-8"?>
-<p:notes xmlns:a="http://schemas.openxmlformats.org/drawingml/2006/main" xmlns:p="http://schemas.openxmlformats.org/presentationml/2006/main" xmlns:r="http://schemas.openxmlformats.org/officeDocument/2006/relationships">
-  <p:cSld>
-    <p:spTree>
-      <p:nvGrpSpPr>
-        <p:cNvPr id="1" name=""/>
-        <p:cNvGrpSpPr/>
-        <p:nvPr/>
-      </p:nvGrpSpPr>
-      <p:grpSpPr>
-        <a:xfrm>
-          <a:off x="0" y="0"/>
-          <a:ext cx="0" cy="0"/>
-          <a:chOff x="0" y="0"/>
-          <a:chExt cx="0" cy="0"/>
-        </a:xfrm>
-      </p:grpSpPr>
-      <p:sp>
-        <p:nvSpPr>
-          <p:cNvPr id="2" name="Slide Image Placeholder 1"/>
-          <p:cNvSpPr>
-            <a:spLocks noGrp="1"/>
-          </p:cNvSpPr>
-          <p:nvPr>
-            <p:ph type="sldImg" idx="2"/>
-          </p:nvPr>
-        </p:nvSpPr>
-        <p:spPr/>
-      </p:sp>
-      <p:sp>
-        <p:nvSpPr>
-          <p:cNvPr id="3" name="Notes Placeholder 2"/>
-          <p:cNvSpPr>
-            <a:spLocks noGrp="1"/>
-          </p:cNvSpPr>
-          <p:nvPr>
-            <p:ph type="body" idx="3" sz="quarter"/>
-          </p:nvPr>
-        </p:nvSpPr>
-        <p:spPr/>
-        <p:txBody>
-          <a:bodyPr/>
-          <a:lstStyle/>
-          <a:p>
-            <a:r>
-              <a:t>≈ 2 min 30.</a:t>
-            </a:r>
-          </a:p>
-          <a:p/>
-          <a:p>
-            <a:r>
-              <a:t>Ne pas faire un catalogue : choisir deux ou trois enjeux et susciter la discussion.</a:t>
-            </a:r>
-          </a:p>
-          <a:p/>
-          <a:p>
-            <a:r>
-              <a:t>Biais : l'outil d'Amazon avait appris à partir des CV reçus pendant dix ans, majoritairement masculins ; il pénalisait par exemple les CV mentionnant un club « féminin ». Leçon directement liée aux TP : un modèle n'est jamais meilleur que ses données.</a:t>
-            </a:r>
-          </a:p>
-          <a:p/>
-          <a:p>
-            <a:r>
-              <a:t>Hallucinations : affaire Mata contre Avianca (2023). Rappeler la diapositive précédente : le modèle produit du texte plausible, pas vérifié.</a:t>
-            </a:r>
-          </a:p>
-          <a:p/>
-          <a:p>
-            <a:r>
-              <a:t>Pour des étudiants en informatique : l'IA transforme déjà le métier de développeur (assistants de code). Savoir vérifier ce qu'elle produit devient essentiel.</a:t>
-            </a:r>
-          </a:p>
-        </p:txBody>
-      </p:sp>
-      <p:sp>
-        <p:nvSpPr>
-          <p:cNvPr id="4" name="Slide Number Placeholder 3"/>
-          <p:cNvSpPr>
-            <a:spLocks noGrp="1"/>
-          </p:cNvSpPr>
-          <p:nvPr>
-            <p:ph type="sldNum" idx="5" sz="quarter"/>
-          </p:nvPr>
-        </p:nvSpPr>
-        <p:spPr/>
-      </p:sp>
-    </p:spTree>
-  </p:cSld>
-  <p:clrMapOvr>
-    <a:masterClrMapping/>
-  </p:clrMapOvr>
-</p:notes>
-</file>
-
-<file path=ppt/notesSlides/notesSlide3.xml><?xml version="1.0" encoding="utf-8"?>
-<p:notes xmlns:a="http://schemas.openxmlformats.org/drawingml/2006/main" xmlns:p="http://schemas.openxmlformats.org/presentationml/2006/main" xmlns:r="http://schemas.openxmlformats.org/officeDocument/2006/relationships">
-  <p:cSld>
-    <p:spTree>
-      <p:nvGrpSpPr>
-        <p:cNvPr id="1" name=""/>
-        <p:cNvGrpSpPr/>
-        <p:nvPr/>
-      </p:nvGrpSpPr>
-      <p:grpSpPr>
-        <a:xfrm>
-          <a:off x="0" y="0"/>
-          <a:ext cx="0" cy="0"/>
-          <a:chOff x="0" y="0"/>
-          <a:chExt cx="0" cy="0"/>
-        </a:xfrm>
-      </p:grpSpPr>
-      <p:sp>
-        <p:nvSpPr>
-          <p:cNvPr id="2" name="Slide Image Placeholder 1"/>
-          <p:cNvSpPr>
-            <a:spLocks noGrp="1"/>
-          </p:cNvSpPr>
-          <p:nvPr>
-            <p:ph type="sldImg" idx="2"/>
-          </p:nvPr>
-        </p:nvSpPr>
-        <p:spPr/>
-      </p:sp>
-      <p:sp>
-        <p:nvSpPr>
-          <p:cNvPr id="3" name="Notes Placeholder 2"/>
-          <p:cNvSpPr>
-            <a:spLocks noGrp="1"/>
-          </p:cNvSpPr>
-          <p:nvPr>
-            <p:ph type="body" idx="3" sz="quarter"/>
-          </p:nvPr>
-        </p:nvSpPr>
-        <p:spPr/>
-        <p:txBody>
-          <a:bodyPr/>
-          <a:lstStyle/>
-          <a:p>
-            <a:r>
-              <a:t>≈ 2 min.</a:t>
-            </a:r>
-          </a:p>
-          <a:p/>
-          <a:p>
-            <a:r>
-              <a:t>Demander d'abord aux étudiants leur propre définition de l'IA.</a:t>
-            </a:r>
-          </a:p>
-          <a:p/>
-          <a:p>
-            <a:r>
-              <a:t>Le schéma est essentiel pour la suite du cours :</a:t>
-            </a:r>
-          </a:p>
-          <a:p>
-            <a:r>
-              <a:t>- l'IA est le domaine général ;</a:t>
-            </a:r>
-          </a:p>
-          <a:p>
-            <a:r>
-              <a:t>- l'apprentissage automatique (machine learning) est la partie de l'IA où la machine apprend à partir de données au lieu d'être programmée règle par règle ;</a:t>
-            </a:r>
-          </a:p>
-          <a:p>
-            <a:r>
-              <a:t>- le deep learning est une famille de méthodes d'apprentissage automatique fondée sur des réseaux de neurones à nombreuses couches ;</a:t>
-            </a:r>
-          </a:p>
-          <a:p>
-            <a:r>
-              <a:t>- l'IA générative (ChatGPT, Midjourney…) est une application récente du deep learning.</a:t>
-            </a:r>
-          </a:p>
-          <a:p/>
-          <a:p>
-            <a:r>
-              <a:t>« Cible mouvante » : c'est l'« effet IA » (AI effect) : dès qu'un problème est résolu, il n'est plus considéré comme de l'intelligence.</a:t>
-            </a:r>
-          </a:p>
-        </p:txBody>
-      </p:sp>
-      <p:sp>
-        <p:nvSpPr>
-          <p:cNvPr id="4" name="Slide Number Placeholder 3"/>
-          <p:cNvSpPr>
-            <a:spLocks noGrp="1"/>
-          </p:cNvSpPr>
-          <p:nvPr>
-            <p:ph type="sldNum" idx="5" sz="quarter"/>
-          </p:nvPr>
-        </p:nvSpPr>
-        <p:spPr/>
-      </p:sp>
-    </p:spTree>
-  </p:cSld>
-  <p:clrMapOvr>
-    <a:masterClrMapping/>
-  </p:clrMapOvr>
-</p:notes>
-</file>
-
-<file path=ppt/notesSlides/notesSlide30.xml><?xml version="1.0" encoding="utf-8"?>
-<p:notes xmlns:a="http://schemas.openxmlformats.org/drawingml/2006/main" xmlns:p="http://schemas.openxmlformats.org/presentationml/2006/main" xmlns:r="http://schemas.openxmlformats.org/officeDocument/2006/relationships">
-  <p:cSld>
-    <p:spTree>
-      <p:nvGrpSpPr>
-        <p:cNvPr id="1" name=""/>
-        <p:cNvGrpSpPr/>
-        <p:nvPr/>
-      </p:nvGrpSpPr>
-      <p:grpSpPr>
-        <a:xfrm>
-          <a:off x="0" y="0"/>
-          <a:ext cx="0" cy="0"/>
-          <a:chOff x="0" y="0"/>
-          <a:chExt cx="0" cy="0"/>
-        </a:xfrm>
-      </p:grpSpPr>
-      <p:sp>
-        <p:nvSpPr>
-          <p:cNvPr id="2" name="Slide Image Placeholder 1"/>
-          <p:cNvSpPr>
-            <a:spLocks noGrp="1"/>
-          </p:cNvSpPr>
-          <p:nvPr>
-            <p:ph type="sldImg" idx="2"/>
-          </p:nvPr>
-        </p:nvSpPr>
-        <p:spPr/>
-      </p:sp>
-      <p:sp>
-        <p:nvSpPr>
-          <p:cNvPr id="3" name="Notes Placeholder 2"/>
-          <p:cNvSpPr>
-            <a:spLocks noGrp="1"/>
-          </p:cNvSpPr>
-          <p:nvPr>
-            <p:ph type="body" idx="3" sz="quarter"/>
-          </p:nvPr>
-        </p:nvSpPr>
-        <p:spPr/>
-        <p:txBody>
-          <a:bodyPr/>
-          <a:lstStyle/>
-          <a:p>
-            <a:r>
-              <a:t>≈ 1 min 30.</a:t>
-            </a:r>
-          </a:p>
-          <a:p/>
-          <a:p>
-            <a:r>
-              <a:t>L'AI Act (règlement européen sur l'intelligence artificielle) est entré en vigueur en août 2024. Les interdictions s'appliquent depuis février 2025, les obligations pour les modèles d'IA à usage général depuis août 2025, et celles pour les systèmes à haut risque à partir de 2026-2027.</a:t>
-            </a:r>
-          </a:p>
-          <a:p/>
-          <a:p>
-            <a:r>
-              <a:t>L'approche par niveaux de risque est la notion à retenir. Exemple parlant : un outil de tri de CV (haut risque) devra démontrer la qualité de ses données et l'absence de discrimination, ce qui fait écho à l'affaire Amazon de la diapositive précédente.</a:t>
-            </a:r>
-          </a:p>
-        </p:txBody>
-      </p:sp>
-      <p:sp>
-        <p:nvSpPr>
-          <p:cNvPr id="4" name="Slide Number Placeholder 3"/>
-          <p:cNvSpPr>
-            <a:spLocks noGrp="1"/>
-          </p:cNvSpPr>
-          <p:nvPr>
-            <p:ph type="sldNum" idx="5" sz="quarter"/>
-          </p:nvPr>
-        </p:nvSpPr>
-        <p:spPr/>
-      </p:sp>
-    </p:spTree>
-  </p:cSld>
-  <p:clrMapOvr>
-    <a:masterClrMapping/>
-  </p:clrMapOvr>
-</p:notes>
-</file>
-
-<file path=ppt/notesSlides/notesSlide31.xml><?xml version="1.0" encoding="utf-8"?>
-<p:notes xmlns:a="http://schemas.openxmlformats.org/drawingml/2006/main" xmlns:p="http://schemas.openxmlformats.org/presentationml/2006/main" xmlns:r="http://schemas.openxmlformats.org/officeDocument/2006/relationships">
-  <p:cSld>
-    <p:spTree>
-      <p:nvGrpSpPr>
-        <p:cNvPr id="1" name=""/>
-        <p:cNvGrpSpPr/>
-        <p:nvPr/>
-      </p:nvGrpSpPr>
-      <p:grpSpPr>
-        <a:xfrm>
-          <a:off x="0" y="0"/>
-          <a:ext cx="0" cy="0"/>
-          <a:chOff x="0" y="0"/>
-          <a:chExt cx="0" cy="0"/>
-        </a:xfrm>
-      </p:grpSpPr>
-      <p:sp>
-        <p:nvSpPr>
-          <p:cNvPr id="2" name="Slide Image Placeholder 1"/>
-          <p:cNvSpPr>
-            <a:spLocks noGrp="1"/>
-          </p:cNvSpPr>
-          <p:nvPr>
-            <p:ph type="sldImg" idx="2"/>
-          </p:nvPr>
-        </p:nvSpPr>
-        <p:spPr/>
-      </p:sp>
-      <p:sp>
-        <p:nvSpPr>
-          <p:cNvPr id="3" name="Notes Placeholder 2"/>
-          <p:cNvSpPr>
-            <a:spLocks noGrp="1"/>
-          </p:cNvSpPr>
-          <p:nvPr>
-            <p:ph type="body" idx="3" sz="quarter"/>
-          </p:nvPr>
-        </p:nvSpPr>
-        <p:spPr/>
-        <p:txBody>
-          <a:bodyPr/>
-          <a:lstStyle/>
-          <a:p>
-            <a:r>
-              <a:t>≈ 1 min 30.</a:t>
-            </a:r>
-          </a:p>
-          <a:p/>
-          <a:p>
-            <a:r>
-              <a:t>Résumer le fil rouge : à chaque étape, on remplace un peu plus ce que l'humain écrivait à la main par ce que la machine apprend à partir de données.</a:t>
-            </a:r>
-          </a:p>
-          <a:p/>
-          <a:p>
-            <a:r>
-              <a:t>Faire le lien avec la suite du cours : même à l'heure de ChatGPT, la grande majorité des modèles en production dans les entreprises sont des modèles d'apprentissage automatique sur données tabulaires (prévision des ventes, détection de fraude, maintenance prédictive…). C'est ce que les étudiants apprendront à construire et à évaluer.</a:t>
-            </a:r>
-          </a:p>
-        </p:txBody>
-      </p:sp>
-      <p:sp>
-        <p:nvSpPr>
-          <p:cNvPr id="4" name="Slide Number Placeholder 3"/>
-          <p:cNvSpPr>
-            <a:spLocks noGrp="1"/>
-          </p:cNvSpPr>
-          <p:nvPr>
-            <p:ph type="sldNum" idx="5" sz="quarter"/>
-          </p:nvPr>
-        </p:nvSpPr>
-        <p:spPr/>
-      </p:sp>
-    </p:spTree>
-  </p:cSld>
-  <p:clrMapOvr>
-    <a:masterClrMapping/>
-  </p:clrMapOvr>
-</p:notes>
-</file>
-
-<file path=ppt/notesSlides/notesSlide32.xml><?xml version="1.0" encoding="utf-8"?>
-<p:notes xmlns:a="http://schemas.openxmlformats.org/drawingml/2006/main" xmlns:p="http://schemas.openxmlformats.org/presentationml/2006/main" xmlns:r="http://schemas.openxmlformats.org/officeDocument/2006/relationships">
-  <p:cSld>
-    <p:spTree>
-      <p:nvGrpSpPr>
-        <p:cNvPr id="1" name=""/>
-        <p:cNvGrpSpPr/>
-        <p:nvPr/>
-      </p:nvGrpSpPr>
-      <p:grpSpPr>
-        <a:xfrm>
-          <a:off x="0" y="0"/>
-          <a:ext cx="0" cy="0"/>
-          <a:chOff x="0" y="0"/>
-          <a:chExt cx="0" cy="0"/>
-        </a:xfrm>
-      </p:grpSpPr>
-      <p:sp>
-        <p:nvSpPr>
-          <p:cNvPr id="2" name="Slide Image Placeholder 1"/>
-          <p:cNvSpPr>
-            <a:spLocks noGrp="1"/>
-          </p:cNvSpPr>
-          <p:nvPr>
-            <p:ph type="sldImg" idx="2"/>
-          </p:nvPr>
-        </p:nvSpPr>
-        <p:spPr/>
-      </p:sp>
-      <p:sp>
-        <p:nvSpPr>
-          <p:cNvPr id="3" name="Notes Placeholder 2"/>
-          <p:cNvSpPr>
-            <a:spLocks noGrp="1"/>
-          </p:cNvSpPr>
-          <p:nvPr>
-            <p:ph type="body" idx="3" sz="quarter"/>
-          </p:nvPr>
-        </p:nvSpPr>
-        <p:spPr/>
-        <p:txBody>
-          <a:bodyPr/>
-          <a:lstStyle/>
-          <a:p>
-            <a:r>
-              <a:t>Prévoir quelques minutes de questions. Pistes si la salle est silencieuse : « Pensez-vous qu'un troisième hiver de l'IA soit possible ? », « ChatGPT passe-t-il le test de Turing ? Est-il intelligent pour autant ? »</a:t>
-            </a:r>
-          </a:p>
-        </p:txBody>
-      </p:sp>
-      <p:sp>
-        <p:nvSpPr>
-          <p:cNvPr id="4" name="Slide Number Placeholder 3"/>
-          <p:cNvSpPr>
-            <a:spLocks noGrp="1"/>
-          </p:cNvSpPr>
-          <p:nvPr>
-            <p:ph type="sldNum" idx="5" sz="quarter"/>
-          </p:nvPr>
-        </p:nvSpPr>
-        <p:spPr/>
-      </p:sp>
-    </p:spTree>
-  </p:cSld>
-  <p:clrMapOvr>
-    <a:masterClrMapping/>
-  </p:clrMapOvr>
-</p:notes>
-</file>
-
-<file path=ppt/notesSlides/notesSlide4.xml><?xml version="1.0" encoding="utf-8"?>
-<p:notes xmlns:a="http://schemas.openxmlformats.org/drawingml/2006/main" xmlns:p="http://schemas.openxmlformats.org/presentationml/2006/main" xmlns:r="http://schemas.openxmlformats.org/officeDocument/2006/relationships">
-  <p:cSld>
-    <p:spTree>
-      <p:nvGrpSpPr>
-        <p:cNvPr id="1" name=""/>
-        <p:cNvGrpSpPr/>
-        <p:nvPr/>
-      </p:nvGrpSpPr>
-      <p:grpSpPr>
-        <a:xfrm>
-          <a:off x="0" y="0"/>
-          <a:ext cx="0" cy="0"/>
-          <a:chOff x="0" y="0"/>
-          <a:chExt cx="0" cy="0"/>
-        </a:xfrm>
-      </p:grpSpPr>
-      <p:sp>
-        <p:nvSpPr>
-          <p:cNvPr id="2" name="Slide Image Placeholder 1"/>
-          <p:cNvSpPr>
-            <a:spLocks noGrp="1"/>
-          </p:cNvSpPr>
-          <p:nvPr>
-            <p:ph type="sldImg" idx="2"/>
-          </p:nvPr>
-        </p:nvSpPr>
-        <p:spPr/>
-      </p:sp>
-      <p:sp>
-        <p:nvSpPr>
-          <p:cNvPr id="3" name="Notes Placeholder 2"/>
-          <p:cNvSpPr>
-            <a:spLocks noGrp="1"/>
-          </p:cNvSpPr>
-          <p:nvPr>
-            <p:ph type="body" idx="3" sz="quarter"/>
-          </p:nvPr>
-        </p:nvSpPr>
-        <p:spPr/>
-        <p:txBody>
-          <a:bodyPr/>
-          <a:lstStyle/>
-          <a:p>
-            <a:r>
-              <a:t>≈ 2 min.</a:t>
-            </a:r>
-          </a:p>
-          <a:p/>
-          <a:p>
-            <a:r>
-              <a:t>Question à la salle : « Combien de fois avez-vous utilisé une IA depuis ce matin ? » La plupart sous-estiment : filtre anti-spam, fil d'actualité, clavier prédictif, GPS, déverrouillage du téléphone…</a:t>
-            </a:r>
-          </a:p>
-          <a:p/>
-          <a:p>
-            <a:r>
-              <a:t>Message : l'IA n'est pas seulement ChatGPT ; l'essentiel des IA en production sont des modèles d'apprentissage automatique « classiques », invisibles, comme ceux que nous verrons en TP.</a:t>
-            </a:r>
-          </a:p>
-        </p:txBody>
-      </p:sp>
-      <p:sp>
-        <p:nvSpPr>
-          <p:cNvPr id="4" name="Slide Number Placeholder 3"/>
-          <p:cNvSpPr>
-            <a:spLocks noGrp="1"/>
-          </p:cNvSpPr>
-          <p:nvPr>
-            <p:ph type="sldNum" idx="5" sz="quarter"/>
-          </p:nvPr>
-        </p:nvSpPr>
-        <p:spPr/>
-      </p:sp>
-    </p:spTree>
-  </p:cSld>
-  <p:clrMapOvr>
-    <a:masterClrMapping/>
-  </p:clrMapOvr>
-</p:notes>
-</file>
-
-<file path=ppt/notesSlides/notesSlide5.xml><?xml version="1.0" encoding="utf-8"?>
-<p:notes xmlns:a="http://schemas.openxmlformats.org/drawingml/2006/main" xmlns:p="http://schemas.openxmlformats.org/presentationml/2006/main" xmlns:r="http://schemas.openxmlformats.org/officeDocument/2006/relationships">
-  <p:cSld>
-    <p:spTree>
-      <p:nvGrpSpPr>
-        <p:cNvPr id="1" name=""/>
-        <p:cNvGrpSpPr/>
-        <p:nvPr/>
-      </p:nvGrpSpPr>
-      <p:grpSpPr>
-        <a:xfrm>
-          <a:off x="0" y="0"/>
-          <a:ext cx="0" cy="0"/>
-          <a:chOff x="0" y="0"/>
-          <a:chExt cx="0" cy="0"/>
-        </a:xfrm>
-      </p:grpSpPr>
-      <p:sp>
-        <p:nvSpPr>
-          <p:cNvPr id="2" name="Slide Image Placeholder 1"/>
-          <p:cNvSpPr>
-            <a:spLocks noGrp="1"/>
-          </p:cNvSpPr>
-          <p:nvPr>
-            <p:ph type="sldImg" idx="2"/>
-          </p:nvPr>
-        </p:nvSpPr>
-        <p:spPr/>
-      </p:sp>
-      <p:sp>
-        <p:nvSpPr>
-          <p:cNvPr id="3" name="Notes Placeholder 2"/>
-          <p:cNvSpPr>
-            <a:spLocks noGrp="1"/>
-          </p:cNvSpPr>
-          <p:nvPr>
-            <p:ph type="body" idx="3" sz="quarter"/>
-          </p:nvPr>
-        </p:nvSpPr>
-        <p:spPr/>
-        <p:txBody>
-          <a:bodyPr/>
-          <a:lstStyle/>
-          <a:p>
-            <a:r>
-              <a:t>≈ 1 min 30.</a:t>
-            </a:r>
-          </a:p>
-          <a:p/>
-          <a:p>
-            <a:r>
-              <a:t>Vue d'ensemble avant d'entrer dans le détail. Faire remarquer :</a:t>
-            </a:r>
-          </a:p>
-          <a:p>
-            <a:r>
-              <a:t>- l'histoire n'est pas linéaire : des phases d'enthousiasme suivies de déceptions (les hivers) ;</a:t>
-            </a:r>
-          </a:p>
-          <a:p>
-            <a:r>
-              <a:t>- l'accélération spectaculaire depuis 2012 ;</a:t>
-            </a:r>
-          </a:p>
-          <a:p>
-            <a:r>
-              <a:t>- les couleurs des époques, qu'on retrouvera sur les diapositives suivantes.</a:t>
-            </a:r>
-          </a:p>
-        </p:txBody>
-      </p:sp>
-      <p:sp>
-        <p:nvSpPr>
-          <p:cNvPr id="4" name="Slide Number Placeholder 3"/>
-          <p:cNvSpPr>
-            <a:spLocks noGrp="1"/>
-          </p:cNvSpPr>
-          <p:nvPr>
-            <p:ph type="sldNum" idx="5" sz="quarter"/>
-          </p:nvPr>
-        </p:nvSpPr>
-        <p:spPr/>
-      </p:sp>
-    </p:spTree>
-  </p:cSld>
-  <p:clrMapOvr>
-    <a:masterClrMapping/>
-  </p:clrMapOvr>
-</p:notes>
-</file>
-
-<file path=ppt/notesSlides/notesSlide6.xml><?xml version="1.0" encoding="utf-8"?>
-<p:notes xmlns:a="http://schemas.openxmlformats.org/drawingml/2006/main" xmlns:p="http://schemas.openxmlformats.org/presentationml/2006/main" xmlns:r="http://schemas.openxmlformats.org/officeDocument/2006/relationships">
-  <p:cSld>
-    <p:spTree>
-      <p:nvGrpSpPr>
-        <p:cNvPr id="1" name=""/>
-        <p:cNvGrpSpPr/>
-        <p:nvPr/>
-      </p:nvGrpSpPr>
-      <p:grpSpPr>
-        <a:xfrm>
-          <a:off x="0" y="0"/>
-          <a:ext cx="0" cy="0"/>
-          <a:chOff x="0" y="0"/>
-          <a:chExt cx="0" cy="0"/>
-        </a:xfrm>
-      </p:grpSpPr>
-      <p:sp>
-        <p:nvSpPr>
-          <p:cNvPr id="2" name="Slide Image Placeholder 1"/>
-          <p:cNvSpPr>
-            <a:spLocks noGrp="1"/>
-          </p:cNvSpPr>
-          <p:nvPr>
-            <p:ph type="sldImg" idx="2"/>
-          </p:nvPr>
-        </p:nvSpPr>
-        <p:spPr/>
-      </p:sp>
-      <p:sp>
-        <p:nvSpPr>
-          <p:cNvPr id="3" name="Notes Placeholder 2"/>
-          <p:cNvSpPr>
-            <a:spLocks noGrp="1"/>
-          </p:cNvSpPr>
-          <p:nvPr>
-            <p:ph type="body" idx="3" sz="quarter"/>
-          </p:nvPr>
-        </p:nvSpPr>
-        <p:spPr/>
-        <p:txBody>
-          <a:bodyPr/>
-          <a:lstStyle/>
-          <a:p>
-            <a:r>
-              <a:t>≈ 15 s. Transition : on remonte aux années 1940, avant même les premiers ordinateurs commerciaux.</a:t>
-            </a:r>
-          </a:p>
-        </p:txBody>
-      </p:sp>
-      <p:sp>
-        <p:nvSpPr>
-          <p:cNvPr id="4" name="Slide Number Placeholder 3"/>
-          <p:cNvSpPr>
-            <a:spLocks noGrp="1"/>
-          </p:cNvSpPr>
-          <p:nvPr>
-            <p:ph type="sldNum" idx="5" sz="quarter"/>
-          </p:nvPr>
-        </p:nvSpPr>
-        <p:spPr/>
-      </p:sp>
-    </p:spTree>
-  </p:cSld>
-  <p:clrMapOvr>
-    <a:masterClrMapping/>
-  </p:clrMapOvr>
-</p:notes>
-</file>
-
-<file path=ppt/notesSlides/notesSlide7.xml><?xml version="1.0" encoding="utf-8"?>
-<p:notes xmlns:a="http://schemas.openxmlformats.org/drawingml/2006/main" xmlns:p="http://schemas.openxmlformats.org/presentationml/2006/main" xmlns:r="http://schemas.openxmlformats.org/officeDocument/2006/relationships">
-  <p:cSld>
-    <p:spTree>
-      <p:nvGrpSpPr>
-        <p:cNvPr id="1" name=""/>
-        <p:cNvGrpSpPr/>
-        <p:nvPr/>
-      </p:nvGrpSpPr>
-      <p:grpSpPr>
-        <a:xfrm>
-          <a:off x="0" y="0"/>
-          <a:ext cx="0" cy="0"/>
-          <a:chOff x="0" y="0"/>
-          <a:chExt cx="0" cy="0"/>
-        </a:xfrm>
-      </p:grpSpPr>
-      <p:sp>
-        <p:nvSpPr>
-          <p:cNvPr id="2" name="Slide Image Placeholder 1"/>
-          <p:cNvSpPr>
-            <a:spLocks noGrp="1"/>
-          </p:cNvSpPr>
-          <p:nvPr>
-            <p:ph type="sldImg" idx="2"/>
-          </p:nvPr>
-        </p:nvSpPr>
-        <p:spPr/>
-      </p:sp>
-      <p:sp>
-        <p:nvSpPr>
-          <p:cNvPr id="3" name="Notes Placeholder 2"/>
-          <p:cNvSpPr>
-            <a:spLocks noGrp="1"/>
-          </p:cNvSpPr>
-          <p:nvPr>
-            <p:ph type="body" idx="3" sz="quarter"/>
-          </p:nvPr>
-        </p:nvSpPr>
-        <p:spPr/>
-        <p:txBody>
-          <a:bodyPr/>
-          <a:lstStyle/>
-          <a:p>
-            <a:r>
-              <a:t>≈ 2 min.</a:t>
-            </a:r>
-          </a:p>
-          <a:p/>
-          <a:p>
-            <a:r>
-              <a:t>1943 : le neurone formel est une idée de biologistes/logiciens, bien avant qu'on sache l'implémenter efficacement. Insister sur le schéma : entrées × poids, somme, seuil. C'est la brique de base de tous les réseaux de neurones, y compris les grands modèles de langage actuels : on la retrouvera en 1958, 1986, 2012 et 2017.</a:t>
-            </a:r>
-          </a:p>
-          <a:p/>
-          <a:p>
-            <a:r>
-              <a:t>1950 : Turing (mathématicien britannique, père de l'informatique théorique) publie « Computing Machinery and Intelligence ».</a:t>
-            </a:r>
-          </a:p>
-          <a:p/>
-          <a:p>
-            <a:r>
-              <a:t>1956 : le séminaire d'été de Dartmouth (New Hampshire) est considéré comme l'acte de naissance du domaine ; John McCarthy y impose le terme « artificial intelligence ».</a:t>
-            </a:r>
-          </a:p>
-        </p:txBody>
-      </p:sp>
-      <p:sp>
-        <p:nvSpPr>
-          <p:cNvPr id="4" name="Slide Number Placeholder 3"/>
-          <p:cNvSpPr>
-            <a:spLocks noGrp="1"/>
-          </p:cNvSpPr>
-          <p:nvPr>
-            <p:ph type="sldNum" idx="5" sz="quarter"/>
-          </p:nvPr>
-        </p:nvSpPr>
-        <p:spPr/>
-      </p:sp>
-    </p:spTree>
-  </p:cSld>
-  <p:clrMapOvr>
-    <a:masterClrMapping/>
-  </p:clrMapOvr>
-</p:notes>
-</file>
-
-<file path=ppt/notesSlides/notesSlide8.xml><?xml version="1.0" encoding="utf-8"?>
-<p:notes xmlns:a="http://schemas.openxmlformats.org/drawingml/2006/main" xmlns:p="http://schemas.openxmlformats.org/presentationml/2006/main" xmlns:r="http://schemas.openxmlformats.org/officeDocument/2006/relationships">
-  <p:cSld>
-    <p:spTree>
-      <p:nvGrpSpPr>
-        <p:cNvPr id="1" name=""/>
-        <p:cNvGrpSpPr/>
-        <p:nvPr/>
-      </p:nvGrpSpPr>
-      <p:grpSpPr>
-        <a:xfrm>
-          <a:off x="0" y="0"/>
-          <a:ext cx="0" cy="0"/>
-          <a:chOff x="0" y="0"/>
-          <a:chExt cx="0" cy="0"/>
-        </a:xfrm>
-      </p:grpSpPr>
-      <p:sp>
-        <p:nvSpPr>
-          <p:cNvPr id="2" name="Slide Image Placeholder 1"/>
-          <p:cNvSpPr>
-            <a:spLocks noGrp="1"/>
-          </p:cNvSpPr>
-          <p:nvPr>
-            <p:ph type="sldImg" idx="2"/>
-          </p:nvPr>
-        </p:nvSpPr>
-        <p:spPr/>
-      </p:sp>
-      <p:sp>
-        <p:nvSpPr>
-          <p:cNvPr id="3" name="Notes Placeholder 2"/>
-          <p:cNvSpPr>
-            <a:spLocks noGrp="1"/>
-          </p:cNvSpPr>
-          <p:nvPr>
-            <p:ph type="body" idx="3" sz="quarter"/>
-          </p:nvPr>
-        </p:nvSpPr>
-        <p:spPr/>
-        <p:txBody>
-          <a:bodyPr/>
-          <a:lstStyle/>
-          <a:p>
-            <a:r>
-              <a:t>≈ 2 min.</a:t>
-            </a:r>
-          </a:p>
-          <a:p/>
-          <a:p>
-            <a:r>
-              <a:t>Turing appelle ce test le « jeu de l'imitation ». Détail amusant : la troisième question du schéma est un piège classique ; une machine trop rapide ou trop exacte se trahit, elle doit donc parfois imiter nos faiblesses.</a:t>
-            </a:r>
-          </a:p>
-          <a:p/>
-          <a:p>
-            <a:r>
-              <a:t>Ouvrir la discussion : un programme qui imite parfaitement une conversation est-il intelligent ? On reviendra sur cette question avec ELIZA (1966) puis avec ChatGPT : l'illusion de compréhension est un fil rouge de l'histoire de l'IA.</a:t>
-            </a:r>
-          </a:p>
-        </p:txBody>
-      </p:sp>
-      <p:sp>
-        <p:nvSpPr>
-          <p:cNvPr id="4" name="Slide Number Placeholder 3"/>
-          <p:cNvSpPr>
-            <a:spLocks noGrp="1"/>
-          </p:cNvSpPr>
-          <p:nvPr>
-            <p:ph type="sldNum" idx="5" sz="quarter"/>
-          </p:nvPr>
-        </p:nvSpPr>
-        <p:spPr/>
-      </p:sp>
-    </p:spTree>
-  </p:cSld>
-  <p:clrMapOvr>
-    <a:masterClrMapping/>
-  </p:clrMapOvr>
-</p:notes>
-</file>
-
-<file path=ppt/notesSlides/notesSlide9.xml><?xml version="1.0" encoding="utf-8"?>
-<p:notes xmlns:a="http://schemas.openxmlformats.org/drawingml/2006/main" xmlns:p="http://schemas.openxmlformats.org/presentationml/2006/main" xmlns:r="http://schemas.openxmlformats.org/officeDocument/2006/relationships">
-  <p:cSld>
-    <p:spTree>
-      <p:nvGrpSpPr>
-        <p:cNvPr id="1" name=""/>
-        <p:cNvGrpSpPr/>
-        <p:nvPr/>
-      </p:nvGrpSpPr>
-      <p:grpSpPr>
-        <a:xfrm>
-          <a:off x="0" y="0"/>
-          <a:ext cx="0" cy="0"/>
-          <a:chOff x="0" y="0"/>
-          <a:chExt cx="0" cy="0"/>
-        </a:xfrm>
-      </p:grpSpPr>
-      <p:sp>
-        <p:nvSpPr>
-          <p:cNvPr id="2" name="Slide Image Placeholder 1"/>
-          <p:cNvSpPr>
-            <a:spLocks noGrp="1"/>
-          </p:cNvSpPr>
-          <p:nvPr>
-            <p:ph type="sldImg" idx="2"/>
-          </p:nvPr>
-        </p:nvSpPr>
-        <p:spPr/>
-      </p:sp>
-      <p:sp>
-        <p:nvSpPr>
-          <p:cNvPr id="3" name="Notes Placeholder 2"/>
-          <p:cNvSpPr>
-            <a:spLocks noGrp="1"/>
-          </p:cNvSpPr>
-          <p:nvPr>
-            <p:ph type="body" idx="3" sz="quarter"/>
-          </p:nvPr>
-        </p:nvSpPr>
-        <p:spPr/>
-        <p:txBody>
-          <a:bodyPr/>
-          <a:lstStyle/>
-          <a:p>
-            <a:r>
-              <a:t>≈ 15 s. Après Dartmouth, vingt ans d'enthousiasme et de financements généreux, surtout militaires (guerre froide).</a:t>
-            </a:r>
-          </a:p>
-        </p:txBody>
-      </p:sp>
-      <p:sp>
-        <p:nvSpPr>
-          <p:cNvPr id="4" name="Slide Number Placeholder 3"/>
-          <p:cNvSpPr>
-            <a:spLocks noGrp="1"/>
-          </p:cNvSpPr>
-          <p:nvPr>
-            <p:ph type="sldNum" idx="5" sz="quarter"/>
-          </p:nvPr>
-        </p:nvSpPr>
-        <p:spPr/>
-      </p:sp>
-    </p:spTree>
-  </p:cSld>
-  <p:clrMapOvr>
-    <a:masterClrMapping/>
-  </p:clrMapOvr>
-</p:notes>
 </file>
 
 <file path=ppt/slideLayouts/slideLayout1.xml><?xml version="1.0" encoding="utf-8"?>

</xml_diff>